<commit_message>
[20260602] Push clase UNLRN
</commit_message>
<xml_diff>
--- a/02_EJERCICIOS_PRACTICOS/Sesión 18 Aprendizaje no supervisado/sesion_18_funciones_no_supervisado.pptx
+++ b/02_EJERCICIOS_PRACTICOS/Sesión 18 Aprendizaje no supervisado/sesion_18_funciones_no_supervisado.pptx
@@ -5,25 +5,25 @@
     <p:sldMasterId id="2147483648" r:id="rId1"/>
   </p:sldMasterIdLst>
   <p:sldIdLst>
-    <p:sldId id="256" r:id="rId7"/>
-    <p:sldId id="257" r:id="rId8"/>
-    <p:sldId id="258" r:id="rId9"/>
-    <p:sldId id="259" r:id="rId10"/>
-    <p:sldId id="260" r:id="rId11"/>
-    <p:sldId id="261" r:id="rId12"/>
-    <p:sldId id="262" r:id="rId13"/>
-    <p:sldId id="263" r:id="rId14"/>
-    <p:sldId id="264" r:id="rId15"/>
-    <p:sldId id="265" r:id="rId16"/>
-    <p:sldId id="266" r:id="rId17"/>
-    <p:sldId id="267" r:id="rId18"/>
-    <p:sldId id="268" r:id="rId19"/>
-    <p:sldId id="269" r:id="rId20"/>
-    <p:sldId id="270" r:id="rId21"/>
-    <p:sldId id="271" r:id="rId22"/>
-    <p:sldId id="272" r:id="rId23"/>
-    <p:sldId id="273" r:id="rId24"/>
-    <p:sldId id="274" r:id="rId25"/>
+    <p:sldId id="256" r:id="rId2"/>
+    <p:sldId id="257" r:id="rId3"/>
+    <p:sldId id="258" r:id="rId4"/>
+    <p:sldId id="259" r:id="rId5"/>
+    <p:sldId id="260" r:id="rId6"/>
+    <p:sldId id="261" r:id="rId7"/>
+    <p:sldId id="262" r:id="rId8"/>
+    <p:sldId id="263" r:id="rId9"/>
+    <p:sldId id="264" r:id="rId10"/>
+    <p:sldId id="265" r:id="rId11"/>
+    <p:sldId id="266" r:id="rId12"/>
+    <p:sldId id="267" r:id="rId13"/>
+    <p:sldId id="268" r:id="rId14"/>
+    <p:sldId id="269" r:id="rId15"/>
+    <p:sldId id="270" r:id="rId16"/>
+    <p:sldId id="271" r:id="rId17"/>
+    <p:sldId id="272" r:id="rId18"/>
+    <p:sldId id="273" r:id="rId19"/>
+    <p:sldId id="274" r:id="rId20"/>
   </p:sldIdLst>
   <p:sldSz cx="9144000" cy="6858000" type="screen4x3"/>
   <p:notesSz cx="6858000" cy="9144000"/>
@@ -122,6 +122,22 @@
       </a:defRPr>
     </a:lvl9pPr>
   </p:defaultTextStyle>
+  <p:extLst>
+    <p:ext uri="{EFAFB233-063F-42B5-8137-9DF3F51BA10A}">
+      <p15:sldGuideLst xmlns:p15="http://schemas.microsoft.com/office/powerpoint/2012/main">
+        <p15:guide id="1" orient="horz" pos="2160">
+          <p15:clr>
+            <a:srgbClr val="A4A3A4"/>
+          </p15:clr>
+        </p15:guide>
+        <p15:guide id="2" pos="2880">
+          <p15:clr>
+            <a:srgbClr val="A4A3A4"/>
+          </p15:clr>
+        </p15:guide>
+      </p15:sldGuideLst>
+    </p:ext>
+  </p:extLst>
 </p:presentation>
 </file>
 
@@ -163,10 +179,9 @@
           <a:lstStyle/>
           <a:p>
             <a:r>
-              <a:rPr lang="en-US" smtClean="0"/>
+              <a:rPr lang="en-US"/>
               <a:t>Click to edit Master title style</a:t>
             </a:r>
-            <a:endParaRPr lang="en-US"/>
           </a:p>
         </p:txBody>
       </p:sp>
@@ -282,10 +297,9 @@
           </a:lstStyle>
           <a:p>
             <a:r>
-              <a:rPr lang="en-US" smtClean="0"/>
+              <a:rPr lang="en-US"/>
               <a:t>Click to edit Master subtitle style</a:t>
             </a:r>
-            <a:endParaRPr lang="en-US"/>
           </a:p>
         </p:txBody>
       </p:sp>
@@ -306,7 +320,7 @@
           <a:p>
             <a:fld id="{5BCAD085-E8A6-8845-BD4E-CB4CCA059FC4}" type="datetimeFigureOut">
               <a:rPr lang="en-US" smtClean="0"/>
-              <a:t>1/27/13</a:t>
+              <a:t>6/2/26</a:t>
             </a:fld>
             <a:endParaRPr lang="en-US"/>
           </a:p>
@@ -348,7 +362,7 @@
           <a:p>
             <a:fld id="{C1FF6DA9-008F-8B48-92A6-B652298478BF}" type="slidenum">
               <a:rPr lang="en-US" smtClean="0"/>
-              <a:t>‹#›</a:t>
+              <a:t>‹Nº›</a:t>
             </a:fld>
             <a:endParaRPr lang="en-US"/>
           </a:p>
@@ -400,10 +414,9 @@
           <a:lstStyle/>
           <a:p>
             <a:r>
-              <a:rPr lang="en-US" smtClean="0"/>
+              <a:rPr lang="en-US"/>
               <a:t>Click to edit Master title style</a:t>
             </a:r>
-            <a:endParaRPr lang="en-US"/>
           </a:p>
         </p:txBody>
       </p:sp>
@@ -424,38 +437,37 @@
           <a:p>
             <a:pPr lvl="0"/>
             <a:r>
-              <a:rPr lang="en-US" smtClean="0"/>
+              <a:rPr lang="en-US"/>
               <a:t>Click to edit Master text styles</a:t>
             </a:r>
           </a:p>
           <a:p>
             <a:pPr lvl="1"/>
             <a:r>
-              <a:rPr lang="en-US" smtClean="0"/>
+              <a:rPr lang="en-US"/>
               <a:t>Second level</a:t>
             </a:r>
           </a:p>
           <a:p>
             <a:pPr lvl="2"/>
             <a:r>
-              <a:rPr lang="en-US" smtClean="0"/>
+              <a:rPr lang="en-US"/>
               <a:t>Third level</a:t>
             </a:r>
           </a:p>
           <a:p>
             <a:pPr lvl="3"/>
             <a:r>
-              <a:rPr lang="en-US" smtClean="0"/>
+              <a:rPr lang="en-US"/>
               <a:t>Fourth level</a:t>
             </a:r>
           </a:p>
           <a:p>
             <a:pPr lvl="4"/>
             <a:r>
-              <a:rPr lang="en-US" smtClean="0"/>
+              <a:rPr lang="en-US"/>
               <a:t>Fifth level</a:t>
             </a:r>
-            <a:endParaRPr lang="en-US"/>
           </a:p>
         </p:txBody>
       </p:sp>
@@ -476,7 +488,7 @@
           <a:p>
             <a:fld id="{5BCAD085-E8A6-8845-BD4E-CB4CCA059FC4}" type="datetimeFigureOut">
               <a:rPr lang="en-US" smtClean="0"/>
-              <a:t>1/27/13</a:t>
+              <a:t>6/2/26</a:t>
             </a:fld>
             <a:endParaRPr lang="en-US"/>
           </a:p>
@@ -518,7 +530,7 @@
           <a:p>
             <a:fld id="{C1FF6DA9-008F-8B48-92A6-B652298478BF}" type="slidenum">
               <a:rPr lang="en-US" smtClean="0"/>
-              <a:t>‹#›</a:t>
+              <a:t>‹Nº›</a:t>
             </a:fld>
             <a:endParaRPr lang="en-US"/>
           </a:p>
@@ -575,10 +587,9 @@
           <a:lstStyle/>
           <a:p>
             <a:r>
-              <a:rPr lang="en-US" smtClean="0"/>
+              <a:rPr lang="en-US"/>
               <a:t>Click to edit Master title style</a:t>
             </a:r>
-            <a:endParaRPr lang="en-US"/>
           </a:p>
         </p:txBody>
       </p:sp>
@@ -604,38 +615,37 @@
           <a:p>
             <a:pPr lvl="0"/>
             <a:r>
-              <a:rPr lang="en-US" smtClean="0"/>
+              <a:rPr lang="en-US"/>
               <a:t>Click to edit Master text styles</a:t>
             </a:r>
           </a:p>
           <a:p>
             <a:pPr lvl="1"/>
             <a:r>
-              <a:rPr lang="en-US" smtClean="0"/>
+              <a:rPr lang="en-US"/>
               <a:t>Second level</a:t>
             </a:r>
           </a:p>
           <a:p>
             <a:pPr lvl="2"/>
             <a:r>
-              <a:rPr lang="en-US" smtClean="0"/>
+              <a:rPr lang="en-US"/>
               <a:t>Third level</a:t>
             </a:r>
           </a:p>
           <a:p>
             <a:pPr lvl="3"/>
             <a:r>
-              <a:rPr lang="en-US" smtClean="0"/>
+              <a:rPr lang="en-US"/>
               <a:t>Fourth level</a:t>
             </a:r>
           </a:p>
           <a:p>
             <a:pPr lvl="4"/>
             <a:r>
-              <a:rPr lang="en-US" smtClean="0"/>
+              <a:rPr lang="en-US"/>
               <a:t>Fifth level</a:t>
             </a:r>
-            <a:endParaRPr lang="en-US"/>
           </a:p>
         </p:txBody>
       </p:sp>
@@ -656,7 +666,7 @@
           <a:p>
             <a:fld id="{5BCAD085-E8A6-8845-BD4E-CB4CCA059FC4}" type="datetimeFigureOut">
               <a:rPr lang="en-US" smtClean="0"/>
-              <a:t>1/27/13</a:t>
+              <a:t>6/2/26</a:t>
             </a:fld>
             <a:endParaRPr lang="en-US"/>
           </a:p>
@@ -698,7 +708,7 @@
           <a:p>
             <a:fld id="{C1FF6DA9-008F-8B48-92A6-B652298478BF}" type="slidenum">
               <a:rPr lang="en-US" smtClean="0"/>
-              <a:t>‹#›</a:t>
+              <a:t>‹Nº›</a:t>
             </a:fld>
             <a:endParaRPr lang="en-US"/>
           </a:p>
@@ -750,10 +760,9 @@
           <a:lstStyle/>
           <a:p>
             <a:r>
-              <a:rPr lang="en-US" smtClean="0"/>
+              <a:rPr lang="en-US"/>
               <a:t>Click to edit Master title style</a:t>
             </a:r>
-            <a:endParaRPr lang="en-US"/>
           </a:p>
         </p:txBody>
       </p:sp>
@@ -774,38 +783,37 @@
           <a:p>
             <a:pPr lvl="0"/>
             <a:r>
-              <a:rPr lang="en-US" smtClean="0"/>
+              <a:rPr lang="en-US"/>
               <a:t>Click to edit Master text styles</a:t>
             </a:r>
           </a:p>
           <a:p>
             <a:pPr lvl="1"/>
             <a:r>
-              <a:rPr lang="en-US" smtClean="0"/>
+              <a:rPr lang="en-US"/>
               <a:t>Second level</a:t>
             </a:r>
           </a:p>
           <a:p>
             <a:pPr lvl="2"/>
             <a:r>
-              <a:rPr lang="en-US" smtClean="0"/>
+              <a:rPr lang="en-US"/>
               <a:t>Third level</a:t>
             </a:r>
           </a:p>
           <a:p>
             <a:pPr lvl="3"/>
             <a:r>
-              <a:rPr lang="en-US" smtClean="0"/>
+              <a:rPr lang="en-US"/>
               <a:t>Fourth level</a:t>
             </a:r>
           </a:p>
           <a:p>
             <a:pPr lvl="4"/>
             <a:r>
-              <a:rPr lang="en-US" smtClean="0"/>
+              <a:rPr lang="en-US"/>
               <a:t>Fifth level</a:t>
             </a:r>
-            <a:endParaRPr lang="en-US"/>
           </a:p>
         </p:txBody>
       </p:sp>
@@ -826,7 +834,7 @@
           <a:p>
             <a:fld id="{5BCAD085-E8A6-8845-BD4E-CB4CCA059FC4}" type="datetimeFigureOut">
               <a:rPr lang="en-US" smtClean="0"/>
-              <a:t>1/27/13</a:t>
+              <a:t>6/2/26</a:t>
             </a:fld>
             <a:endParaRPr lang="en-US"/>
           </a:p>
@@ -868,7 +876,7 @@
           <a:p>
             <a:fld id="{C1FF6DA9-008F-8B48-92A6-B652298478BF}" type="slidenum">
               <a:rPr lang="en-US" smtClean="0"/>
-              <a:t>‹#›</a:t>
+              <a:t>‹Nº›</a:t>
             </a:fld>
             <a:endParaRPr lang="en-US"/>
           </a:p>
@@ -929,10 +937,9 @@
           </a:lstStyle>
           <a:p>
             <a:r>
-              <a:rPr lang="en-US" smtClean="0"/>
+              <a:rPr lang="en-US"/>
               <a:t>Click to edit Master title style</a:t>
             </a:r>
-            <a:endParaRPr lang="en-US"/>
           </a:p>
         </p:txBody>
       </p:sp>
@@ -1049,7 +1056,7 @@
           <a:p>
             <a:pPr lvl="0"/>
             <a:r>
-              <a:rPr lang="en-US" smtClean="0"/>
+              <a:rPr lang="en-US"/>
               <a:t>Click to edit Master text styles</a:t>
             </a:r>
           </a:p>
@@ -1072,7 +1079,7 @@
           <a:p>
             <a:fld id="{5BCAD085-E8A6-8845-BD4E-CB4CCA059FC4}" type="datetimeFigureOut">
               <a:rPr lang="en-US" smtClean="0"/>
-              <a:t>1/27/13</a:t>
+              <a:t>6/2/26</a:t>
             </a:fld>
             <a:endParaRPr lang="en-US"/>
           </a:p>
@@ -1114,7 +1121,7 @@
           <a:p>
             <a:fld id="{C1FF6DA9-008F-8B48-92A6-B652298478BF}" type="slidenum">
               <a:rPr lang="en-US" smtClean="0"/>
-              <a:t>‹#›</a:t>
+              <a:t>‹Nº›</a:t>
             </a:fld>
             <a:endParaRPr lang="en-US"/>
           </a:p>
@@ -1166,10 +1173,9 @@
           <a:lstStyle/>
           <a:p>
             <a:r>
-              <a:rPr lang="en-US" smtClean="0"/>
+              <a:rPr lang="en-US"/>
               <a:t>Click to edit Master title style</a:t>
             </a:r>
-            <a:endParaRPr lang="en-US"/>
           </a:p>
         </p:txBody>
       </p:sp>
@@ -1223,38 +1229,37 @@
           <a:p>
             <a:pPr lvl="0"/>
             <a:r>
-              <a:rPr lang="en-US" smtClean="0"/>
+              <a:rPr lang="en-US"/>
               <a:t>Click to edit Master text styles</a:t>
             </a:r>
           </a:p>
           <a:p>
             <a:pPr lvl="1"/>
             <a:r>
-              <a:rPr lang="en-US" smtClean="0"/>
+              <a:rPr lang="en-US"/>
               <a:t>Second level</a:t>
             </a:r>
           </a:p>
           <a:p>
             <a:pPr lvl="2"/>
             <a:r>
-              <a:rPr lang="en-US" smtClean="0"/>
+              <a:rPr lang="en-US"/>
               <a:t>Third level</a:t>
             </a:r>
           </a:p>
           <a:p>
             <a:pPr lvl="3"/>
             <a:r>
-              <a:rPr lang="en-US" smtClean="0"/>
+              <a:rPr lang="en-US"/>
               <a:t>Fourth level</a:t>
             </a:r>
           </a:p>
           <a:p>
             <a:pPr lvl="4"/>
             <a:r>
-              <a:rPr lang="en-US" smtClean="0"/>
+              <a:rPr lang="en-US"/>
               <a:t>Fifth level</a:t>
             </a:r>
-            <a:endParaRPr lang="en-US"/>
           </a:p>
         </p:txBody>
       </p:sp>
@@ -1308,38 +1313,37 @@
           <a:p>
             <a:pPr lvl="0"/>
             <a:r>
-              <a:rPr lang="en-US" smtClean="0"/>
+              <a:rPr lang="en-US"/>
               <a:t>Click to edit Master text styles</a:t>
             </a:r>
           </a:p>
           <a:p>
             <a:pPr lvl="1"/>
             <a:r>
-              <a:rPr lang="en-US" smtClean="0"/>
+              <a:rPr lang="en-US"/>
               <a:t>Second level</a:t>
             </a:r>
           </a:p>
           <a:p>
             <a:pPr lvl="2"/>
             <a:r>
-              <a:rPr lang="en-US" smtClean="0"/>
+              <a:rPr lang="en-US"/>
               <a:t>Third level</a:t>
             </a:r>
           </a:p>
           <a:p>
             <a:pPr lvl="3"/>
             <a:r>
-              <a:rPr lang="en-US" smtClean="0"/>
+              <a:rPr lang="en-US"/>
               <a:t>Fourth level</a:t>
             </a:r>
           </a:p>
           <a:p>
             <a:pPr lvl="4"/>
             <a:r>
-              <a:rPr lang="en-US" smtClean="0"/>
+              <a:rPr lang="en-US"/>
               <a:t>Fifth level</a:t>
             </a:r>
-            <a:endParaRPr lang="en-US"/>
           </a:p>
         </p:txBody>
       </p:sp>
@@ -1360,7 +1364,7 @@
           <a:p>
             <a:fld id="{5BCAD085-E8A6-8845-BD4E-CB4CCA059FC4}" type="datetimeFigureOut">
               <a:rPr lang="en-US" smtClean="0"/>
-              <a:t>1/27/13</a:t>
+              <a:t>6/2/26</a:t>
             </a:fld>
             <a:endParaRPr lang="en-US"/>
           </a:p>
@@ -1402,7 +1406,7 @@
           <a:p>
             <a:fld id="{C1FF6DA9-008F-8B48-92A6-B652298478BF}" type="slidenum">
               <a:rPr lang="en-US" smtClean="0"/>
-              <a:t>‹#›</a:t>
+              <a:t>‹Nº›</a:t>
             </a:fld>
             <a:endParaRPr lang="en-US"/>
           </a:p>
@@ -1458,10 +1462,9 @@
           </a:lstStyle>
           <a:p>
             <a:r>
-              <a:rPr lang="en-US" smtClean="0"/>
+              <a:rPr lang="en-US"/>
               <a:t>Click to edit Master title style</a:t>
             </a:r>
-            <a:endParaRPr lang="en-US"/>
           </a:p>
         </p:txBody>
       </p:sp>
@@ -1524,7 +1527,7 @@
           <a:p>
             <a:pPr lvl="0"/>
             <a:r>
-              <a:rPr lang="en-US" smtClean="0"/>
+              <a:rPr lang="en-US"/>
               <a:t>Click to edit Master text styles</a:t>
             </a:r>
           </a:p>
@@ -1580,38 +1583,37 @@
           <a:p>
             <a:pPr lvl="0"/>
             <a:r>
-              <a:rPr lang="en-US" smtClean="0"/>
+              <a:rPr lang="en-US"/>
               <a:t>Click to edit Master text styles</a:t>
             </a:r>
           </a:p>
           <a:p>
             <a:pPr lvl="1"/>
             <a:r>
-              <a:rPr lang="en-US" smtClean="0"/>
+              <a:rPr lang="en-US"/>
               <a:t>Second level</a:t>
             </a:r>
           </a:p>
           <a:p>
             <a:pPr lvl="2"/>
             <a:r>
-              <a:rPr lang="en-US" smtClean="0"/>
+              <a:rPr lang="en-US"/>
               <a:t>Third level</a:t>
             </a:r>
           </a:p>
           <a:p>
             <a:pPr lvl="3"/>
             <a:r>
-              <a:rPr lang="en-US" smtClean="0"/>
+              <a:rPr lang="en-US"/>
               <a:t>Fourth level</a:t>
             </a:r>
           </a:p>
           <a:p>
             <a:pPr lvl="4"/>
             <a:r>
-              <a:rPr lang="en-US" smtClean="0"/>
+              <a:rPr lang="en-US"/>
               <a:t>Fifth level</a:t>
             </a:r>
-            <a:endParaRPr lang="en-US"/>
           </a:p>
         </p:txBody>
       </p:sp>
@@ -1674,7 +1676,7 @@
           <a:p>
             <a:pPr lvl="0"/>
             <a:r>
-              <a:rPr lang="en-US" smtClean="0"/>
+              <a:rPr lang="en-US"/>
               <a:t>Click to edit Master text styles</a:t>
             </a:r>
           </a:p>
@@ -1730,38 +1732,37 @@
           <a:p>
             <a:pPr lvl="0"/>
             <a:r>
-              <a:rPr lang="en-US" smtClean="0"/>
+              <a:rPr lang="en-US"/>
               <a:t>Click to edit Master text styles</a:t>
             </a:r>
           </a:p>
           <a:p>
             <a:pPr lvl="1"/>
             <a:r>
-              <a:rPr lang="en-US" smtClean="0"/>
+              <a:rPr lang="en-US"/>
               <a:t>Second level</a:t>
             </a:r>
           </a:p>
           <a:p>
             <a:pPr lvl="2"/>
             <a:r>
-              <a:rPr lang="en-US" smtClean="0"/>
+              <a:rPr lang="en-US"/>
               <a:t>Third level</a:t>
             </a:r>
           </a:p>
           <a:p>
             <a:pPr lvl="3"/>
             <a:r>
-              <a:rPr lang="en-US" smtClean="0"/>
+              <a:rPr lang="en-US"/>
               <a:t>Fourth level</a:t>
             </a:r>
           </a:p>
           <a:p>
             <a:pPr lvl="4"/>
             <a:r>
-              <a:rPr lang="en-US" smtClean="0"/>
+              <a:rPr lang="en-US"/>
               <a:t>Fifth level</a:t>
             </a:r>
-            <a:endParaRPr lang="en-US"/>
           </a:p>
         </p:txBody>
       </p:sp>
@@ -1782,7 +1783,7 @@
           <a:p>
             <a:fld id="{5BCAD085-E8A6-8845-BD4E-CB4CCA059FC4}" type="datetimeFigureOut">
               <a:rPr lang="en-US" smtClean="0"/>
-              <a:t>1/27/13</a:t>
+              <a:t>6/2/26</a:t>
             </a:fld>
             <a:endParaRPr lang="en-US"/>
           </a:p>
@@ -1824,7 +1825,7 @@
           <a:p>
             <a:fld id="{C1FF6DA9-008F-8B48-92A6-B652298478BF}" type="slidenum">
               <a:rPr lang="en-US" smtClean="0"/>
-              <a:t>‹#›</a:t>
+              <a:t>‹Nº›</a:t>
             </a:fld>
             <a:endParaRPr lang="en-US"/>
           </a:p>
@@ -1876,10 +1877,9 @@
           <a:lstStyle/>
           <a:p>
             <a:r>
-              <a:rPr lang="en-US" smtClean="0"/>
+              <a:rPr lang="en-US"/>
               <a:t>Click to edit Master title style</a:t>
             </a:r>
-            <a:endParaRPr lang="en-US"/>
           </a:p>
         </p:txBody>
       </p:sp>
@@ -1900,7 +1900,7 @@
           <a:p>
             <a:fld id="{5BCAD085-E8A6-8845-BD4E-CB4CCA059FC4}" type="datetimeFigureOut">
               <a:rPr lang="en-US" smtClean="0"/>
-              <a:t>1/27/13</a:t>
+              <a:t>6/2/26</a:t>
             </a:fld>
             <a:endParaRPr lang="en-US"/>
           </a:p>
@@ -1942,7 +1942,7 @@
           <a:p>
             <a:fld id="{C1FF6DA9-008F-8B48-92A6-B652298478BF}" type="slidenum">
               <a:rPr lang="en-US" smtClean="0"/>
-              <a:t>‹#›</a:t>
+              <a:t>‹Nº›</a:t>
             </a:fld>
             <a:endParaRPr lang="en-US"/>
           </a:p>
@@ -1995,7 +1995,7 @@
           <a:p>
             <a:fld id="{5BCAD085-E8A6-8845-BD4E-CB4CCA059FC4}" type="datetimeFigureOut">
               <a:rPr lang="en-US" smtClean="0"/>
-              <a:t>1/27/13</a:t>
+              <a:t>6/2/26</a:t>
             </a:fld>
             <a:endParaRPr lang="en-US"/>
           </a:p>
@@ -2037,7 +2037,7 @@
           <a:p>
             <a:fld id="{C1FF6DA9-008F-8B48-92A6-B652298478BF}" type="slidenum">
               <a:rPr lang="en-US" smtClean="0"/>
-              <a:t>‹#›</a:t>
+              <a:t>‹Nº›</a:t>
             </a:fld>
             <a:endParaRPr lang="en-US"/>
           </a:p>
@@ -2098,10 +2098,9 @@
           </a:lstStyle>
           <a:p>
             <a:r>
-              <a:rPr lang="en-US" smtClean="0"/>
+              <a:rPr lang="en-US"/>
               <a:t>Click to edit Master title style</a:t>
             </a:r>
-            <a:endParaRPr lang="en-US"/>
           </a:p>
         </p:txBody>
       </p:sp>
@@ -2155,38 +2154,37 @@
           <a:p>
             <a:pPr lvl="0"/>
             <a:r>
-              <a:rPr lang="en-US" smtClean="0"/>
+              <a:rPr lang="en-US"/>
               <a:t>Click to edit Master text styles</a:t>
             </a:r>
           </a:p>
           <a:p>
             <a:pPr lvl="1"/>
             <a:r>
-              <a:rPr lang="en-US" smtClean="0"/>
+              <a:rPr lang="en-US"/>
               <a:t>Second level</a:t>
             </a:r>
           </a:p>
           <a:p>
             <a:pPr lvl="2"/>
             <a:r>
-              <a:rPr lang="en-US" smtClean="0"/>
+              <a:rPr lang="en-US"/>
               <a:t>Third level</a:t>
             </a:r>
           </a:p>
           <a:p>
             <a:pPr lvl="3"/>
             <a:r>
-              <a:rPr lang="en-US" smtClean="0"/>
+              <a:rPr lang="en-US"/>
               <a:t>Fourth level</a:t>
             </a:r>
           </a:p>
           <a:p>
             <a:pPr lvl="4"/>
             <a:r>
-              <a:rPr lang="en-US" smtClean="0"/>
+              <a:rPr lang="en-US"/>
               <a:t>Fifth level</a:t>
             </a:r>
-            <a:endParaRPr lang="en-US"/>
           </a:p>
         </p:txBody>
       </p:sp>
@@ -2249,7 +2247,7 @@
           <a:p>
             <a:pPr lvl="0"/>
             <a:r>
-              <a:rPr lang="en-US" smtClean="0"/>
+              <a:rPr lang="en-US"/>
               <a:t>Click to edit Master text styles</a:t>
             </a:r>
           </a:p>
@@ -2272,7 +2270,7 @@
           <a:p>
             <a:fld id="{5BCAD085-E8A6-8845-BD4E-CB4CCA059FC4}" type="datetimeFigureOut">
               <a:rPr lang="en-US" smtClean="0"/>
-              <a:t>1/27/13</a:t>
+              <a:t>6/2/26</a:t>
             </a:fld>
             <a:endParaRPr lang="en-US"/>
           </a:p>
@@ -2314,7 +2312,7 @@
           <a:p>
             <a:fld id="{C1FF6DA9-008F-8B48-92A6-B652298478BF}" type="slidenum">
               <a:rPr lang="en-US" smtClean="0"/>
-              <a:t>‹#›</a:t>
+              <a:t>‹Nº›</a:t>
             </a:fld>
             <a:endParaRPr lang="en-US"/>
           </a:p>
@@ -2375,10 +2373,9 @@
           </a:lstStyle>
           <a:p>
             <a:r>
-              <a:rPr lang="en-US" smtClean="0"/>
+              <a:rPr lang="en-US"/>
               <a:t>Click to edit Master title style</a:t>
             </a:r>
-            <a:endParaRPr lang="en-US"/>
           </a:p>
         </p:txBody>
       </p:sp>
@@ -2502,7 +2499,7 @@
           <a:p>
             <a:pPr lvl="0"/>
             <a:r>
-              <a:rPr lang="en-US" smtClean="0"/>
+              <a:rPr lang="en-US"/>
               <a:t>Click to edit Master text styles</a:t>
             </a:r>
           </a:p>
@@ -2525,7 +2522,7 @@
           <a:p>
             <a:fld id="{5BCAD085-E8A6-8845-BD4E-CB4CCA059FC4}" type="datetimeFigureOut">
               <a:rPr lang="en-US" smtClean="0"/>
-              <a:t>1/27/13</a:t>
+              <a:t>6/2/26</a:t>
             </a:fld>
             <a:endParaRPr lang="en-US"/>
           </a:p>
@@ -2567,7 +2564,7 @@
           <a:p>
             <a:fld id="{C1FF6DA9-008F-8B48-92A6-B652298478BF}" type="slidenum">
               <a:rPr lang="en-US" smtClean="0"/>
-              <a:t>‹#›</a:t>
+              <a:t>‹Nº›</a:t>
             </a:fld>
             <a:endParaRPr lang="en-US"/>
           </a:p>
@@ -2634,10 +2631,9 @@
           <a:lstStyle/>
           <a:p>
             <a:r>
-              <a:rPr lang="en-US" smtClean="0"/>
+              <a:rPr lang="en-US"/>
               <a:t>Click to edit Master title style</a:t>
             </a:r>
-            <a:endParaRPr lang="en-US"/>
           </a:p>
         </p:txBody>
       </p:sp>
@@ -2668,38 +2664,37 @@
           <a:p>
             <a:pPr lvl="0"/>
             <a:r>
-              <a:rPr lang="en-US" smtClean="0"/>
+              <a:rPr lang="en-US"/>
               <a:t>Click to edit Master text styles</a:t>
             </a:r>
           </a:p>
           <a:p>
             <a:pPr lvl="1"/>
             <a:r>
-              <a:rPr lang="en-US" smtClean="0"/>
+              <a:rPr lang="en-US"/>
               <a:t>Second level</a:t>
             </a:r>
           </a:p>
           <a:p>
             <a:pPr lvl="2"/>
             <a:r>
-              <a:rPr lang="en-US" smtClean="0"/>
+              <a:rPr lang="en-US"/>
               <a:t>Third level</a:t>
             </a:r>
           </a:p>
           <a:p>
             <a:pPr lvl="3"/>
             <a:r>
-              <a:rPr lang="en-US" smtClean="0"/>
+              <a:rPr lang="en-US"/>
               <a:t>Fourth level</a:t>
             </a:r>
           </a:p>
           <a:p>
             <a:pPr lvl="4"/>
             <a:r>
-              <a:rPr lang="en-US" smtClean="0"/>
+              <a:rPr lang="en-US"/>
               <a:t>Fifth level</a:t>
             </a:r>
-            <a:endParaRPr lang="en-US"/>
           </a:p>
         </p:txBody>
       </p:sp>
@@ -2738,7 +2733,7 @@
           <a:p>
             <a:fld id="{5BCAD085-E8A6-8845-BD4E-CB4CCA059FC4}" type="datetimeFigureOut">
               <a:rPr lang="en-US" smtClean="0"/>
-              <a:t>1/27/13</a:t>
+              <a:t>6/2/26</a:t>
             </a:fld>
             <a:endParaRPr lang="en-US"/>
           </a:p>
@@ -2816,7 +2811,7 @@
           <a:p>
             <a:fld id="{C1FF6DA9-008F-8B48-92A6-B652298478BF}" type="slidenum">
               <a:rPr lang="en-US" smtClean="0"/>
-              <a:t>‹#›</a:t>
+              <a:t>‹Nº›</a:t>
             </a:fld>
             <a:endParaRPr lang="en-US"/>
           </a:p>
@@ -3097,7 +3092,7 @@
 </file>
 
 <file path=ppt/slides/slide1.xml><?xml version="1.0" encoding="utf-8"?>
-<p:sld xmlns:a="http://schemas.openxmlformats.org/drawingml/2006/main" xmlns:p="http://schemas.openxmlformats.org/presentationml/2006/main" xmlns:r="http://schemas.openxmlformats.org/officeDocument/2006/relationships">
+<p:sld xmlns:a="http://schemas.openxmlformats.org/drawingml/2006/main" xmlns:r="http://schemas.openxmlformats.org/officeDocument/2006/relationships" xmlns:p="http://schemas.openxmlformats.org/presentationml/2006/main">
   <p:cSld>
     <p:spTree>
       <p:nvGrpSpPr>
@@ -3105,7 +3100,14 @@
         <p:cNvGrpSpPr/>
         <p:nvPr/>
       </p:nvGrpSpPr>
-      <p:grpSpPr/>
+      <p:grpSpPr>
+        <a:xfrm>
+          <a:off x="0" y="0"/>
+          <a:ext cx="0" cy="0"/>
+          <a:chOff x="0" y="0"/>
+          <a:chExt cx="0" cy="0"/>
+        </a:xfrm>
+      </p:grpSpPr>
       <p:sp>
         <p:nvSpPr>
           <p:cNvPr id="2" name="Rectangle 1"/>
@@ -3147,6 +3149,7 @@
           <a:lstStyle/>
           <a:p>
             <a:pPr algn="ctr"/>
+            <a:endParaRPr/>
           </a:p>
         </p:txBody>
       </p:sp>
@@ -3191,6 +3194,7 @@
           <a:lstStyle/>
           <a:p>
             <a:pPr algn="ctr"/>
+            <a:endParaRPr/>
           </a:p>
         </p:txBody>
       </p:sp>
@@ -3211,7 +3215,7 @@
           <a:noFill/>
         </p:spPr>
         <p:txBody>
-          <a:bodyPr wrap="square" lIns="0" rIns="0" tIns="0" bIns="0" anchor="ctr">
+          <a:bodyPr wrap="square" lIns="0" tIns="0" rIns="0" bIns="0" anchor="ctr">
             <a:spAutoFit/>
           </a:bodyPr>
           <a:lstStyle/>
@@ -3270,6 +3274,7 @@
           <a:lstStyle/>
           <a:p>
             <a:pPr algn="ctr"/>
+            <a:endParaRPr/>
           </a:p>
         </p:txBody>
       </p:sp>
@@ -3282,7 +3287,7 @@
         <p:spPr>
           <a:xfrm>
             <a:off x="548640" y="1554480"/>
-            <a:ext cx="8046720" cy="1828800"/>
+            <a:ext cx="8046720" cy="1234890"/>
           </a:xfrm>
           <a:prstGeom prst="rect">
             <a:avLst/>
@@ -3290,7 +3295,7 @@
           <a:noFill/>
         </p:spPr>
         <p:txBody>
-          <a:bodyPr wrap="square" lIns="0" rIns="0" tIns="0" bIns="0">
+          <a:bodyPr wrap="square" lIns="0" tIns="0" rIns="0" bIns="0">
             <a:spAutoFit/>
           </a:bodyPr>
           <a:lstStyle/>
@@ -3301,13 +3306,40 @@
               </a:lnSpc>
             </a:pPr>
             <a:r>
-              <a:rPr sz="4000" b="1" i="0">
-                <a:solidFill>
-                  <a:srgbClr val="1E4C7D"/>
-                </a:solidFill>
-                <a:latin typeface="Ubuntu"/>
-              </a:rPr>
-              <a:t>Sesión 18: Aprendizaje no</a:t>
+              <a:rPr sz="4000" b="1" i="0" dirty="0" err="1">
+                <a:solidFill>
+                  <a:srgbClr val="FF0000"/>
+                </a:solidFill>
+                <a:latin typeface="Ubuntu"/>
+              </a:rPr>
+              <a:t>Sesión</a:t>
+            </a:r>
+            <a:r>
+              <a:rPr sz="4000" b="1" i="0" dirty="0">
+                <a:solidFill>
+                  <a:srgbClr val="FF0000"/>
+                </a:solidFill>
+                <a:latin typeface="Ubuntu"/>
+              </a:rPr>
+              <a:t> 18: </a:t>
+            </a:r>
+            <a:r>
+              <a:rPr sz="4000" b="1" i="0" dirty="0" err="1">
+                <a:solidFill>
+                  <a:srgbClr val="FF0000"/>
+                </a:solidFill>
+                <a:latin typeface="Ubuntu"/>
+              </a:rPr>
+              <a:t>Aprendizaje</a:t>
+            </a:r>
+            <a:r>
+              <a:rPr sz="4000" b="1" i="0" dirty="0">
+                <a:solidFill>
+                  <a:srgbClr val="FF0000"/>
+                </a:solidFill>
+                <a:latin typeface="Ubuntu"/>
+              </a:rPr>
+              <a:t> no</a:t>
             </a:r>
           </a:p>
           <a:p>
@@ -3317,13 +3349,22 @@
               </a:lnSpc>
             </a:pPr>
             <a:r>
-              <a:rPr sz="4000" b="1" i="0">
-                <a:solidFill>
-                  <a:srgbClr val="1E4C7D"/>
-                </a:solidFill>
-                <a:latin typeface="Ubuntu"/>
-              </a:rPr>
-              <a:t>supervisado (clustering + PCA)</a:t>
+              <a:rPr sz="4000" b="1" i="0" dirty="0" err="1">
+                <a:solidFill>
+                  <a:srgbClr val="FF0000"/>
+                </a:solidFill>
+                <a:latin typeface="Ubuntu"/>
+              </a:rPr>
+              <a:t>supervisado</a:t>
+            </a:r>
+            <a:r>
+              <a:rPr sz="4000" b="1" i="0" dirty="0">
+                <a:solidFill>
+                  <a:srgbClr val="FF0000"/>
+                </a:solidFill>
+                <a:latin typeface="Ubuntu"/>
+              </a:rPr>
+              <a:t> (clustering + PCA)</a:t>
             </a:r>
           </a:p>
         </p:txBody>
@@ -3345,7 +3386,7 @@
           <a:noFill/>
         </p:spPr>
         <p:txBody>
-          <a:bodyPr wrap="square" lIns="0" rIns="0" tIns="0" bIns="0">
+          <a:bodyPr wrap="square" lIns="0" tIns="0" rIns="0" bIns="0">
             <a:spAutoFit/>
           </a:bodyPr>
           <a:lstStyle/>
@@ -3380,7 +3421,7 @@
           <a:noFill/>
         </p:spPr>
         <p:txBody>
-          <a:bodyPr wrap="square" lIns="0" rIns="0" tIns="0" bIns="0">
+          <a:bodyPr wrap="square" lIns="0" tIns="0" rIns="0" bIns="0">
             <a:spAutoFit/>
           </a:bodyPr>
           <a:lstStyle/>
@@ -3459,6 +3500,7 @@
           <a:lstStyle/>
           <a:p>
             <a:pPr algn="ctr"/>
+            <a:endParaRPr/>
           </a:p>
         </p:txBody>
       </p:sp>
@@ -3471,7 +3513,7 @@
 </file>
 
 <file path=ppt/slides/slide10.xml><?xml version="1.0" encoding="utf-8"?>
-<p:sld xmlns:a="http://schemas.openxmlformats.org/drawingml/2006/main" xmlns:p="http://schemas.openxmlformats.org/presentationml/2006/main" xmlns:r="http://schemas.openxmlformats.org/officeDocument/2006/relationships">
+<p:sld xmlns:a="http://schemas.openxmlformats.org/drawingml/2006/main" xmlns:r="http://schemas.openxmlformats.org/officeDocument/2006/relationships" xmlns:p="http://schemas.openxmlformats.org/presentationml/2006/main">
   <p:cSld>
     <p:spTree>
       <p:nvGrpSpPr>
@@ -3479,7 +3521,14 @@
         <p:cNvGrpSpPr/>
         <p:nvPr/>
       </p:nvGrpSpPr>
-      <p:grpSpPr/>
+      <p:grpSpPr>
+        <a:xfrm>
+          <a:off x="0" y="0"/>
+          <a:ext cx="0" cy="0"/>
+          <a:chOff x="0" y="0"/>
+          <a:chExt cx="0" cy="0"/>
+        </a:xfrm>
+      </p:grpSpPr>
       <p:sp>
         <p:nvSpPr>
           <p:cNvPr id="2" name="Rectangle 1"/>
@@ -3521,6 +3570,7 @@
           <a:lstStyle/>
           <a:p>
             <a:pPr algn="ctr"/>
+            <a:endParaRPr/>
           </a:p>
         </p:txBody>
       </p:sp>
@@ -3565,6 +3615,7 @@
           <a:lstStyle/>
           <a:p>
             <a:pPr algn="ctr"/>
+            <a:endParaRPr/>
           </a:p>
         </p:txBody>
       </p:sp>
@@ -3585,7 +3636,7 @@
           <a:noFill/>
         </p:spPr>
         <p:txBody>
-          <a:bodyPr wrap="square" lIns="0" rIns="0" tIns="0" bIns="0" anchor="ctr">
+          <a:bodyPr wrap="square" lIns="0" tIns="0" rIns="0" bIns="0" anchor="ctr">
             <a:spAutoFit/>
           </a:bodyPr>
           <a:lstStyle/>
@@ -3620,7 +3671,7 @@
           <a:noFill/>
         </p:spPr>
         <p:txBody>
-          <a:bodyPr wrap="square" lIns="0" rIns="0" tIns="0" bIns="0">
+          <a:bodyPr wrap="square" lIns="0" tIns="0" rIns="0" bIns="0">
             <a:spAutoFit/>
           </a:bodyPr>
           <a:lstStyle/>
@@ -3659,7 +3710,7 @@
           <a:noFill/>
         </p:spPr>
         <p:txBody>
-          <a:bodyPr wrap="square" lIns="0" rIns="0" tIns="0" bIns="0">
+          <a:bodyPr wrap="square" lIns="0" tIns="0" rIns="0" bIns="0">
             <a:spAutoFit/>
           </a:bodyPr>
           <a:lstStyle/>
@@ -3718,6 +3769,7 @@
           <a:lstStyle/>
           <a:p>
             <a:pPr algn="ctr"/>
+            <a:endParaRPr/>
           </a:p>
         </p:txBody>
       </p:sp>
@@ -3738,7 +3790,7 @@
           <a:noFill/>
         </p:spPr>
         <p:txBody>
-          <a:bodyPr wrap="none" lIns="0" rIns="0" tIns="0" bIns="0">
+          <a:bodyPr wrap="none" lIns="0" tIns="0" rIns="0" bIns="0">
             <a:spAutoFit/>
           </a:bodyPr>
           <a:lstStyle/>
@@ -3849,6 +3901,7 @@
           <a:lstStyle/>
           <a:p>
             <a:pPr algn="ctr"/>
+            <a:endParaRPr/>
           </a:p>
         </p:txBody>
       </p:sp>
@@ -3869,7 +3922,7 @@
           <a:noFill/>
         </p:spPr>
         <p:txBody>
-          <a:bodyPr wrap="square" lIns="0" rIns="0" tIns="0" bIns="0">
+          <a:bodyPr wrap="square" lIns="0" tIns="0" rIns="0" bIns="0">
             <a:spAutoFit/>
           </a:bodyPr>
           <a:lstStyle/>
@@ -3904,7 +3957,7 @@
           <a:noFill/>
         </p:spPr>
         <p:txBody>
-          <a:bodyPr wrap="square" lIns="0" rIns="0" tIns="0" bIns="0">
+          <a:bodyPr wrap="square" lIns="0" tIns="0" rIns="0" bIns="0">
             <a:spAutoFit/>
           </a:bodyPr>
           <a:lstStyle/>
@@ -3975,7 +4028,7 @@
           <a:noFill/>
         </p:spPr>
         <p:txBody>
-          <a:bodyPr wrap="square" lIns="0" rIns="0" tIns="0" bIns="0">
+          <a:bodyPr wrap="square" lIns="0" tIns="0" rIns="0" bIns="0">
             <a:spAutoFit/>
           </a:bodyPr>
           <a:lstStyle/>
@@ -4002,7 +4055,7 @@
 </file>
 
 <file path=ppt/slides/slide11.xml><?xml version="1.0" encoding="utf-8"?>
-<p:sld xmlns:a="http://schemas.openxmlformats.org/drawingml/2006/main" xmlns:p="http://schemas.openxmlformats.org/presentationml/2006/main" xmlns:r="http://schemas.openxmlformats.org/officeDocument/2006/relationships">
+<p:sld xmlns:a="http://schemas.openxmlformats.org/drawingml/2006/main" xmlns:r="http://schemas.openxmlformats.org/officeDocument/2006/relationships" xmlns:p="http://schemas.openxmlformats.org/presentationml/2006/main">
   <p:cSld>
     <p:spTree>
       <p:nvGrpSpPr>
@@ -4010,7 +4063,14 @@
         <p:cNvGrpSpPr/>
         <p:nvPr/>
       </p:nvGrpSpPr>
-      <p:grpSpPr/>
+      <p:grpSpPr>
+        <a:xfrm>
+          <a:off x="0" y="0"/>
+          <a:ext cx="0" cy="0"/>
+          <a:chOff x="0" y="0"/>
+          <a:chExt cx="0" cy="0"/>
+        </a:xfrm>
+      </p:grpSpPr>
       <p:sp>
         <p:nvSpPr>
           <p:cNvPr id="2" name="Rectangle 1"/>
@@ -4052,6 +4112,7 @@
           <a:lstStyle/>
           <a:p>
             <a:pPr algn="ctr"/>
+            <a:endParaRPr/>
           </a:p>
         </p:txBody>
       </p:sp>
@@ -4096,6 +4157,7 @@
           <a:lstStyle/>
           <a:p>
             <a:pPr algn="ctr"/>
+            <a:endParaRPr/>
           </a:p>
         </p:txBody>
       </p:sp>
@@ -4116,7 +4178,7 @@
           <a:noFill/>
         </p:spPr>
         <p:txBody>
-          <a:bodyPr wrap="square" lIns="0" rIns="0" tIns="0" bIns="0" anchor="ctr">
+          <a:bodyPr wrap="square" lIns="0" tIns="0" rIns="0" bIns="0" anchor="ctr">
             <a:spAutoFit/>
           </a:bodyPr>
           <a:lstStyle/>
@@ -4151,7 +4213,7 @@
           <a:noFill/>
         </p:spPr>
         <p:txBody>
-          <a:bodyPr wrap="square" lIns="0" rIns="0" tIns="0" bIns="0">
+          <a:bodyPr wrap="square" lIns="0" tIns="0" rIns="0" bIns="0">
             <a:spAutoFit/>
           </a:bodyPr>
           <a:lstStyle/>
@@ -4190,7 +4252,7 @@
           <a:noFill/>
         </p:spPr>
         <p:txBody>
-          <a:bodyPr wrap="square" lIns="0" rIns="0" tIns="0" bIns="0">
+          <a:bodyPr wrap="square" lIns="0" tIns="0" rIns="0" bIns="0">
             <a:spAutoFit/>
           </a:bodyPr>
           <a:lstStyle/>
@@ -4249,6 +4311,7 @@
           <a:lstStyle/>
           <a:p>
             <a:pPr algn="ctr"/>
+            <a:endParaRPr/>
           </a:p>
         </p:txBody>
       </p:sp>
@@ -4269,7 +4332,7 @@
           <a:noFill/>
         </p:spPr>
         <p:txBody>
-          <a:bodyPr wrap="none" lIns="0" rIns="0" tIns="0" bIns="0">
+          <a:bodyPr wrap="none" lIns="0" tIns="0" rIns="0" bIns="0">
             <a:spAutoFit/>
           </a:bodyPr>
           <a:lstStyle/>
@@ -4380,6 +4443,7 @@
           <a:lstStyle/>
           <a:p>
             <a:pPr algn="ctr"/>
+            <a:endParaRPr/>
           </a:p>
         </p:txBody>
       </p:sp>
@@ -4400,7 +4464,7 @@
           <a:noFill/>
         </p:spPr>
         <p:txBody>
-          <a:bodyPr wrap="square" lIns="0" rIns="0" tIns="0" bIns="0">
+          <a:bodyPr wrap="square" lIns="0" tIns="0" rIns="0" bIns="0">
             <a:spAutoFit/>
           </a:bodyPr>
           <a:lstStyle/>
@@ -4435,7 +4499,7 @@
           <a:noFill/>
         </p:spPr>
         <p:txBody>
-          <a:bodyPr wrap="square" lIns="0" rIns="0" tIns="0" bIns="0">
+          <a:bodyPr wrap="square" lIns="0" tIns="0" rIns="0" bIns="0">
             <a:spAutoFit/>
           </a:bodyPr>
           <a:lstStyle/>
@@ -4506,7 +4570,7 @@
           <a:noFill/>
         </p:spPr>
         <p:txBody>
-          <a:bodyPr wrap="square" lIns="0" rIns="0" tIns="0" bIns="0">
+          <a:bodyPr wrap="square" lIns="0" tIns="0" rIns="0" bIns="0">
             <a:spAutoFit/>
           </a:bodyPr>
           <a:lstStyle/>
@@ -4533,7 +4597,7 @@
 </file>
 
 <file path=ppt/slides/slide12.xml><?xml version="1.0" encoding="utf-8"?>
-<p:sld xmlns:a="http://schemas.openxmlformats.org/drawingml/2006/main" xmlns:p="http://schemas.openxmlformats.org/presentationml/2006/main" xmlns:r="http://schemas.openxmlformats.org/officeDocument/2006/relationships">
+<p:sld xmlns:a="http://schemas.openxmlformats.org/drawingml/2006/main" xmlns:r="http://schemas.openxmlformats.org/officeDocument/2006/relationships" xmlns:p="http://schemas.openxmlformats.org/presentationml/2006/main">
   <p:cSld>
     <p:spTree>
       <p:nvGrpSpPr>
@@ -4541,51 +4605,14 @@
         <p:cNvGrpSpPr/>
         <p:nvPr/>
       </p:nvGrpSpPr>
-      <p:grpSpPr/>
-      <p:sp>
-        <p:nvSpPr>
-          <p:cNvPr id="2" name="Rectangle 1"/>
-          <p:cNvSpPr/>
-          <p:nvPr/>
-        </p:nvSpPr>
-        <p:spPr>
-          <a:xfrm>
-            <a:off x="0" y="0"/>
-            <a:ext cx="9144000" cy="6858000"/>
-          </a:xfrm>
-          <a:prstGeom prst="rect">
-            <a:avLst/>
-          </a:prstGeom>
-          <a:solidFill>
-            <a:srgbClr val="FFFFFF"/>
-          </a:solidFill>
-          <a:ln>
-            <a:noFill/>
-          </a:ln>
-          <a:effectLst/>
-        </p:spPr>
-        <p:style>
-          <a:lnRef idx="1">
-            <a:schemeClr val="accent1"/>
-          </a:lnRef>
-          <a:fillRef idx="3">
-            <a:schemeClr val="accent1"/>
-          </a:fillRef>
-          <a:effectRef idx="2">
-            <a:schemeClr val="accent1"/>
-          </a:effectRef>
-          <a:fontRef idx="minor">
-            <a:schemeClr val="lt1"/>
-          </a:fontRef>
-        </p:style>
-        <p:txBody>
-          <a:bodyPr rtlCol="0" anchor="ctr"/>
-          <a:lstStyle/>
-          <a:p>
-            <a:pPr algn="ctr"/>
-          </a:p>
-        </p:txBody>
-      </p:sp>
+      <p:grpSpPr>
+        <a:xfrm>
+          <a:off x="0" y="0"/>
+          <a:ext cx="0" cy="0"/>
+          <a:chOff x="0" y="0"/>
+          <a:chExt cx="0" cy="0"/>
+        </a:xfrm>
+      </p:grpSpPr>
       <p:sp>
         <p:nvSpPr>
           <p:cNvPr id="3" name="Rectangle 2"/>
@@ -4594,8 +4621,8 @@
         </p:nvSpPr>
         <p:spPr>
           <a:xfrm>
-            <a:off x="0" y="274320"/>
-            <a:ext cx="5486400" cy="658368"/>
+            <a:off x="-1" y="274320"/>
+            <a:ext cx="6467707" cy="658368"/>
           </a:xfrm>
           <a:prstGeom prst="rect">
             <a:avLst/>
@@ -4627,6 +4654,7 @@
           <a:lstStyle/>
           <a:p>
             <a:pPr algn="ctr"/>
+            <a:endParaRPr/>
           </a:p>
         </p:txBody>
       </p:sp>
@@ -4638,8 +4666,8 @@
         </p:nvSpPr>
         <p:spPr>
           <a:xfrm>
-            <a:off x="228600" y="274320"/>
-            <a:ext cx="5212080" cy="658368"/>
+            <a:off x="228599" y="434227"/>
+            <a:ext cx="5670395" cy="338554"/>
           </a:xfrm>
           <a:prstGeom prst="rect">
             <a:avLst/>
@@ -4647,20 +4675,29 @@
           <a:noFill/>
         </p:spPr>
         <p:txBody>
-          <a:bodyPr wrap="square" lIns="0" rIns="0" tIns="0" bIns="0" anchor="ctr">
+          <a:bodyPr wrap="square" lIns="0" tIns="0" rIns="0" bIns="0" anchor="ctr">
             <a:spAutoFit/>
           </a:bodyPr>
           <a:lstStyle/>
           <a:p>
             <a:pPr algn="l"/>
             <a:r>
-              <a:rPr sz="2200" b="1" i="0">
+              <a:rPr sz="2200" b="1" i="0" dirty="0" err="1">
                 <a:solidFill>
                   <a:srgbClr val="FFFFFF"/>
                 </a:solidFill>
                 <a:latin typeface="Menlo"/>
               </a:rPr>
-              <a:t>fviz_nbclust(method="silhouette")</a:t>
+              <a:t>fviz_nbclust</a:t>
+            </a:r>
+            <a:r>
+              <a:rPr sz="2200" b="1" i="0" dirty="0">
+                <a:solidFill>
+                  <a:srgbClr val="FFFFFF"/>
+                </a:solidFill>
+                <a:latin typeface="Menlo"/>
+              </a:rPr>
+              <a:t>(method="silhouette")</a:t>
             </a:r>
           </a:p>
         </p:txBody>
@@ -4682,7 +4719,7 @@
           <a:noFill/>
         </p:spPr>
         <p:txBody>
-          <a:bodyPr wrap="square" lIns="0" rIns="0" tIns="0" bIns="0">
+          <a:bodyPr wrap="square" lIns="0" tIns="0" rIns="0" bIns="0">
             <a:spAutoFit/>
           </a:bodyPr>
           <a:lstStyle/>
@@ -4721,7 +4758,7 @@
           <a:noFill/>
         </p:spPr>
         <p:txBody>
-          <a:bodyPr wrap="square" lIns="0" rIns="0" tIns="0" bIns="0">
+          <a:bodyPr wrap="square" lIns="0" tIns="0" rIns="0" bIns="0">
             <a:spAutoFit/>
           </a:bodyPr>
           <a:lstStyle/>
@@ -4780,6 +4817,7 @@
           <a:lstStyle/>
           <a:p>
             <a:pPr algn="ctr"/>
+            <a:endParaRPr/>
           </a:p>
         </p:txBody>
       </p:sp>
@@ -4800,7 +4838,7 @@
           <a:noFill/>
         </p:spPr>
         <p:txBody>
-          <a:bodyPr wrap="none" lIns="0" rIns="0" tIns="0" bIns="0">
+          <a:bodyPr wrap="none" lIns="0" tIns="0" rIns="0" bIns="0">
             <a:spAutoFit/>
           </a:bodyPr>
           <a:lstStyle/>
@@ -4911,6 +4949,7 @@
           <a:lstStyle/>
           <a:p>
             <a:pPr algn="ctr"/>
+            <a:endParaRPr/>
           </a:p>
         </p:txBody>
       </p:sp>
@@ -4931,7 +4970,7 @@
           <a:noFill/>
         </p:spPr>
         <p:txBody>
-          <a:bodyPr wrap="square" lIns="0" rIns="0" tIns="0" bIns="0">
+          <a:bodyPr wrap="square" lIns="0" tIns="0" rIns="0" bIns="0">
             <a:spAutoFit/>
           </a:bodyPr>
           <a:lstStyle/>
@@ -4966,7 +5005,7 @@
           <a:noFill/>
         </p:spPr>
         <p:txBody>
-          <a:bodyPr wrap="square" lIns="0" rIns="0" tIns="0" bIns="0">
+          <a:bodyPr wrap="square" lIns="0" tIns="0" rIns="0" bIns="0">
             <a:spAutoFit/>
           </a:bodyPr>
           <a:lstStyle/>
@@ -5037,7 +5076,7 @@
           <a:noFill/>
         </p:spPr>
         <p:txBody>
-          <a:bodyPr wrap="square" lIns="0" rIns="0" tIns="0" bIns="0">
+          <a:bodyPr wrap="square" lIns="0" tIns="0" rIns="0" bIns="0">
             <a:spAutoFit/>
           </a:bodyPr>
           <a:lstStyle/>
@@ -5064,7 +5103,7 @@
 </file>
 
 <file path=ppt/slides/slide13.xml><?xml version="1.0" encoding="utf-8"?>
-<p:sld xmlns:a="http://schemas.openxmlformats.org/drawingml/2006/main" xmlns:p="http://schemas.openxmlformats.org/presentationml/2006/main" xmlns:r="http://schemas.openxmlformats.org/officeDocument/2006/relationships">
+<p:sld xmlns:a="http://schemas.openxmlformats.org/drawingml/2006/main" xmlns:r="http://schemas.openxmlformats.org/officeDocument/2006/relationships" xmlns:p="http://schemas.openxmlformats.org/presentationml/2006/main">
   <p:cSld>
     <p:spTree>
       <p:nvGrpSpPr>
@@ -5072,7 +5111,14 @@
         <p:cNvGrpSpPr/>
         <p:nvPr/>
       </p:nvGrpSpPr>
-      <p:grpSpPr/>
+      <p:grpSpPr>
+        <a:xfrm>
+          <a:off x="0" y="0"/>
+          <a:ext cx="0" cy="0"/>
+          <a:chOff x="0" y="0"/>
+          <a:chExt cx="0" cy="0"/>
+        </a:xfrm>
+      </p:grpSpPr>
       <p:sp>
         <p:nvSpPr>
           <p:cNvPr id="2" name="Rectangle 1"/>
@@ -5114,6 +5160,7 @@
           <a:lstStyle/>
           <a:p>
             <a:pPr algn="ctr"/>
+            <a:endParaRPr/>
           </a:p>
         </p:txBody>
       </p:sp>
@@ -5158,6 +5205,7 @@
           <a:lstStyle/>
           <a:p>
             <a:pPr algn="ctr"/>
+            <a:endParaRPr/>
           </a:p>
         </p:txBody>
       </p:sp>
@@ -5178,7 +5226,7 @@
           <a:noFill/>
         </p:spPr>
         <p:txBody>
-          <a:bodyPr wrap="square" lIns="0" rIns="0" tIns="0" bIns="0" anchor="ctr">
+          <a:bodyPr wrap="square" lIns="0" tIns="0" rIns="0" bIns="0" anchor="ctr">
             <a:spAutoFit/>
           </a:bodyPr>
           <a:lstStyle/>
@@ -5213,7 +5261,7 @@
           <a:noFill/>
         </p:spPr>
         <p:txBody>
-          <a:bodyPr wrap="square" lIns="0" rIns="0" tIns="0" bIns="0">
+          <a:bodyPr wrap="square" lIns="0" tIns="0" rIns="0" bIns="0">
             <a:spAutoFit/>
           </a:bodyPr>
           <a:lstStyle/>
@@ -5252,7 +5300,7 @@
           <a:noFill/>
         </p:spPr>
         <p:txBody>
-          <a:bodyPr wrap="square" lIns="0" rIns="0" tIns="0" bIns="0">
+          <a:bodyPr wrap="square" lIns="0" tIns="0" rIns="0" bIns="0">
             <a:spAutoFit/>
           </a:bodyPr>
           <a:lstStyle/>
@@ -5311,6 +5359,7 @@
           <a:lstStyle/>
           <a:p>
             <a:pPr algn="ctr"/>
+            <a:endParaRPr/>
           </a:p>
         </p:txBody>
       </p:sp>
@@ -5331,7 +5380,7 @@
           <a:noFill/>
         </p:spPr>
         <p:txBody>
-          <a:bodyPr wrap="none" lIns="0" rIns="0" tIns="0" bIns="0">
+          <a:bodyPr wrap="none" lIns="0" tIns="0" rIns="0" bIns="0">
             <a:spAutoFit/>
           </a:bodyPr>
           <a:lstStyle/>
@@ -5474,6 +5523,7 @@
           <a:lstStyle/>
           <a:p>
             <a:pPr algn="ctr"/>
+            <a:endParaRPr/>
           </a:p>
         </p:txBody>
       </p:sp>
@@ -5494,7 +5544,7 @@
           <a:noFill/>
         </p:spPr>
         <p:txBody>
-          <a:bodyPr wrap="square" lIns="0" rIns="0" tIns="0" bIns="0">
+          <a:bodyPr wrap="square" lIns="0" tIns="0" rIns="0" bIns="0">
             <a:spAutoFit/>
           </a:bodyPr>
           <a:lstStyle/>
@@ -5529,7 +5579,7 @@
           <a:noFill/>
         </p:spPr>
         <p:txBody>
-          <a:bodyPr wrap="square" lIns="0" rIns="0" tIns="0" bIns="0">
+          <a:bodyPr wrap="square" lIns="0" tIns="0" rIns="0" bIns="0">
             <a:spAutoFit/>
           </a:bodyPr>
           <a:lstStyle/>
@@ -5600,7 +5650,7 @@
           <a:noFill/>
         </p:spPr>
         <p:txBody>
-          <a:bodyPr wrap="square" lIns="0" rIns="0" tIns="0" bIns="0">
+          <a:bodyPr wrap="square" lIns="0" tIns="0" rIns="0" bIns="0">
             <a:spAutoFit/>
           </a:bodyPr>
           <a:lstStyle/>
@@ -5627,7 +5677,7 @@
 </file>
 
 <file path=ppt/slides/slide14.xml><?xml version="1.0" encoding="utf-8"?>
-<p:sld xmlns:a="http://schemas.openxmlformats.org/drawingml/2006/main" xmlns:p="http://schemas.openxmlformats.org/presentationml/2006/main" xmlns:r="http://schemas.openxmlformats.org/officeDocument/2006/relationships">
+<p:sld xmlns:a="http://schemas.openxmlformats.org/drawingml/2006/main" xmlns:r="http://schemas.openxmlformats.org/officeDocument/2006/relationships" xmlns:p="http://schemas.openxmlformats.org/presentationml/2006/main">
   <p:cSld>
     <p:spTree>
       <p:nvGrpSpPr>
@@ -5635,7 +5685,14 @@
         <p:cNvGrpSpPr/>
         <p:nvPr/>
       </p:nvGrpSpPr>
-      <p:grpSpPr/>
+      <p:grpSpPr>
+        <a:xfrm>
+          <a:off x="0" y="0"/>
+          <a:ext cx="0" cy="0"/>
+          <a:chOff x="0" y="0"/>
+          <a:chExt cx="0" cy="0"/>
+        </a:xfrm>
+      </p:grpSpPr>
       <p:sp>
         <p:nvSpPr>
           <p:cNvPr id="2" name="Rectangle 1"/>
@@ -5677,6 +5734,7 @@
           <a:lstStyle/>
           <a:p>
             <a:pPr algn="ctr"/>
+            <a:endParaRPr/>
           </a:p>
         </p:txBody>
       </p:sp>
@@ -5721,6 +5779,7 @@
           <a:lstStyle/>
           <a:p>
             <a:pPr algn="ctr"/>
+            <a:endParaRPr/>
           </a:p>
         </p:txBody>
       </p:sp>
@@ -5741,7 +5800,7 @@
           <a:noFill/>
         </p:spPr>
         <p:txBody>
-          <a:bodyPr wrap="square" lIns="0" rIns="0" tIns="0" bIns="0" anchor="ctr">
+          <a:bodyPr wrap="square" lIns="0" tIns="0" rIns="0" bIns="0" anchor="ctr">
             <a:spAutoFit/>
           </a:bodyPr>
           <a:lstStyle/>
@@ -5776,7 +5835,7 @@
           <a:noFill/>
         </p:spPr>
         <p:txBody>
-          <a:bodyPr wrap="square" lIns="0" rIns="0" tIns="0" bIns="0">
+          <a:bodyPr wrap="square" lIns="0" tIns="0" rIns="0" bIns="0">
             <a:spAutoFit/>
           </a:bodyPr>
           <a:lstStyle/>
@@ -5815,7 +5874,7 @@
           <a:noFill/>
         </p:spPr>
         <p:txBody>
-          <a:bodyPr wrap="square" lIns="0" rIns="0" tIns="0" bIns="0">
+          <a:bodyPr wrap="square" lIns="0" tIns="0" rIns="0" bIns="0">
             <a:spAutoFit/>
           </a:bodyPr>
           <a:lstStyle/>
@@ -5874,6 +5933,7 @@
           <a:lstStyle/>
           <a:p>
             <a:pPr algn="ctr"/>
+            <a:endParaRPr/>
           </a:p>
         </p:txBody>
       </p:sp>
@@ -5894,7 +5954,7 @@
           <a:noFill/>
         </p:spPr>
         <p:txBody>
-          <a:bodyPr wrap="none" lIns="0" rIns="0" tIns="0" bIns="0">
+          <a:bodyPr wrap="none" lIns="0" tIns="0" rIns="0" bIns="0">
             <a:spAutoFit/>
           </a:bodyPr>
           <a:lstStyle/>
@@ -6021,6 +6081,7 @@
           <a:lstStyle/>
           <a:p>
             <a:pPr algn="ctr"/>
+            <a:endParaRPr/>
           </a:p>
         </p:txBody>
       </p:sp>
@@ -6041,7 +6102,7 @@
           <a:noFill/>
         </p:spPr>
         <p:txBody>
-          <a:bodyPr wrap="square" lIns="0" rIns="0" tIns="0" bIns="0">
+          <a:bodyPr wrap="square" lIns="0" tIns="0" rIns="0" bIns="0">
             <a:spAutoFit/>
           </a:bodyPr>
           <a:lstStyle/>
@@ -6076,7 +6137,7 @@
           <a:noFill/>
         </p:spPr>
         <p:txBody>
-          <a:bodyPr wrap="square" lIns="0" rIns="0" tIns="0" bIns="0">
+          <a:bodyPr wrap="square" lIns="0" tIns="0" rIns="0" bIns="0">
             <a:spAutoFit/>
           </a:bodyPr>
           <a:lstStyle/>
@@ -6147,7 +6208,7 @@
           <a:noFill/>
         </p:spPr>
         <p:txBody>
-          <a:bodyPr wrap="square" lIns="0" rIns="0" tIns="0" bIns="0">
+          <a:bodyPr wrap="square" lIns="0" tIns="0" rIns="0" bIns="0">
             <a:spAutoFit/>
           </a:bodyPr>
           <a:lstStyle/>
@@ -6174,7 +6235,7 @@
 </file>
 
 <file path=ppt/slides/slide15.xml><?xml version="1.0" encoding="utf-8"?>
-<p:sld xmlns:a="http://schemas.openxmlformats.org/drawingml/2006/main" xmlns:p="http://schemas.openxmlformats.org/presentationml/2006/main" xmlns:r="http://schemas.openxmlformats.org/officeDocument/2006/relationships">
+<p:sld xmlns:a="http://schemas.openxmlformats.org/drawingml/2006/main" xmlns:r="http://schemas.openxmlformats.org/officeDocument/2006/relationships" xmlns:p="http://schemas.openxmlformats.org/presentationml/2006/main">
   <p:cSld>
     <p:spTree>
       <p:nvGrpSpPr>
@@ -6182,7 +6243,14 @@
         <p:cNvGrpSpPr/>
         <p:nvPr/>
       </p:nvGrpSpPr>
-      <p:grpSpPr/>
+      <p:grpSpPr>
+        <a:xfrm>
+          <a:off x="0" y="0"/>
+          <a:ext cx="0" cy="0"/>
+          <a:chOff x="0" y="0"/>
+          <a:chExt cx="0" cy="0"/>
+        </a:xfrm>
+      </p:grpSpPr>
       <p:sp>
         <p:nvSpPr>
           <p:cNvPr id="2" name="Rectangle 1"/>
@@ -6191,7 +6259,7 @@
         </p:nvSpPr>
         <p:spPr>
           <a:xfrm>
-            <a:off x="0" y="0"/>
+            <a:off x="0" y="11151"/>
             <a:ext cx="9144000" cy="6858000"/>
           </a:xfrm>
           <a:prstGeom prst="rect">
@@ -6224,6 +6292,7 @@
           <a:lstStyle/>
           <a:p>
             <a:pPr algn="ctr"/>
+            <a:endParaRPr/>
           </a:p>
         </p:txBody>
       </p:sp>
@@ -6236,7 +6305,7 @@
         <p:spPr>
           <a:xfrm>
             <a:off x="0" y="274320"/>
-            <a:ext cx="5486400" cy="658368"/>
+            <a:ext cx="7482468" cy="658368"/>
           </a:xfrm>
           <a:prstGeom prst="rect">
             <a:avLst/>
@@ -6268,6 +6337,7 @@
           <a:lstStyle/>
           <a:p>
             <a:pPr algn="ctr"/>
+            <a:endParaRPr/>
           </a:p>
         </p:txBody>
       </p:sp>
@@ -6279,8 +6349,8 @@
         </p:nvSpPr>
         <p:spPr>
           <a:xfrm>
-            <a:off x="228600" y="274320"/>
-            <a:ext cx="5212080" cy="658368"/>
+            <a:off x="228600" y="434227"/>
+            <a:ext cx="5781907" cy="338554"/>
           </a:xfrm>
           <a:prstGeom prst="rect">
             <a:avLst/>
@@ -6288,20 +6358,47 @@
           <a:noFill/>
         </p:spPr>
         <p:txBody>
-          <a:bodyPr wrap="square" lIns="0" rIns="0" tIns="0" bIns="0" anchor="ctr">
+          <a:bodyPr wrap="square" lIns="0" tIns="0" rIns="0" bIns="0" anchor="ctr">
             <a:spAutoFit/>
           </a:bodyPr>
           <a:lstStyle/>
           <a:p>
             <a:pPr algn="l"/>
             <a:r>
-              <a:rPr sz="2200" b="1" i="0">
+              <a:rPr sz="2200" b="1" i="0" dirty="0" err="1">
                 <a:solidFill>
                   <a:srgbClr val="FFFFFF"/>
                 </a:solidFill>
                 <a:latin typeface="Menlo"/>
               </a:rPr>
-              <a:t>group_by() + summarise(across())</a:t>
+              <a:t>group_by</a:t>
+            </a:r>
+            <a:r>
+              <a:rPr sz="2200" b="1" i="0" dirty="0">
+                <a:solidFill>
+                  <a:srgbClr val="FFFFFF"/>
+                </a:solidFill>
+                <a:latin typeface="Menlo"/>
+              </a:rPr>
+              <a:t>() + </a:t>
+            </a:r>
+            <a:r>
+              <a:rPr sz="2200" b="1" i="0" dirty="0" err="1">
+                <a:solidFill>
+                  <a:srgbClr val="FFFFFF"/>
+                </a:solidFill>
+                <a:latin typeface="Menlo"/>
+              </a:rPr>
+              <a:t>summarise</a:t>
+            </a:r>
+            <a:r>
+              <a:rPr sz="2200" b="1" i="0" dirty="0">
+                <a:solidFill>
+                  <a:srgbClr val="FFFFFF"/>
+                </a:solidFill>
+                <a:latin typeface="Menlo"/>
+              </a:rPr>
+              <a:t>(across())</a:t>
             </a:r>
           </a:p>
         </p:txBody>
@@ -6323,7 +6420,7 @@
           <a:noFill/>
         </p:spPr>
         <p:txBody>
-          <a:bodyPr wrap="square" lIns="0" rIns="0" tIns="0" bIns="0">
+          <a:bodyPr wrap="square" lIns="0" tIns="0" rIns="0" bIns="0">
             <a:spAutoFit/>
           </a:bodyPr>
           <a:lstStyle/>
@@ -6362,7 +6459,7 @@
           <a:noFill/>
         </p:spPr>
         <p:txBody>
-          <a:bodyPr wrap="square" lIns="0" rIns="0" tIns="0" bIns="0">
+          <a:bodyPr wrap="square" lIns="0" tIns="0" rIns="0" bIns="0">
             <a:spAutoFit/>
           </a:bodyPr>
           <a:lstStyle/>
@@ -6421,6 +6518,7 @@
           <a:lstStyle/>
           <a:p>
             <a:pPr algn="ctr"/>
+            <a:endParaRPr/>
           </a:p>
         </p:txBody>
       </p:sp>
@@ -6441,7 +6539,7 @@
           <a:noFill/>
         </p:spPr>
         <p:txBody>
-          <a:bodyPr wrap="none" lIns="0" rIns="0" tIns="0" bIns="0">
+          <a:bodyPr wrap="none" lIns="0" tIns="0" rIns="0" bIns="0">
             <a:spAutoFit/>
           </a:bodyPr>
           <a:lstStyle/>
@@ -6600,6 +6698,7 @@
           <a:lstStyle/>
           <a:p>
             <a:pPr algn="ctr"/>
+            <a:endParaRPr/>
           </a:p>
         </p:txBody>
       </p:sp>
@@ -6620,7 +6719,7 @@
           <a:noFill/>
         </p:spPr>
         <p:txBody>
-          <a:bodyPr wrap="square" lIns="0" rIns="0" tIns="0" bIns="0">
+          <a:bodyPr wrap="square" lIns="0" tIns="0" rIns="0" bIns="0">
             <a:spAutoFit/>
           </a:bodyPr>
           <a:lstStyle/>
@@ -6655,7 +6754,7 @@
           <a:noFill/>
         </p:spPr>
         <p:txBody>
-          <a:bodyPr wrap="square" lIns="0" rIns="0" tIns="0" bIns="0">
+          <a:bodyPr wrap="square" lIns="0" tIns="0" rIns="0" bIns="0">
             <a:spAutoFit/>
           </a:bodyPr>
           <a:lstStyle/>
@@ -6726,7 +6825,7 @@
           <a:noFill/>
         </p:spPr>
         <p:txBody>
-          <a:bodyPr wrap="square" lIns="0" rIns="0" tIns="0" bIns="0">
+          <a:bodyPr wrap="square" lIns="0" tIns="0" rIns="0" bIns="0">
             <a:spAutoFit/>
           </a:bodyPr>
           <a:lstStyle/>
@@ -6753,7 +6852,7 @@
 </file>
 
 <file path=ppt/slides/slide16.xml><?xml version="1.0" encoding="utf-8"?>
-<p:sld xmlns:a="http://schemas.openxmlformats.org/drawingml/2006/main" xmlns:p="http://schemas.openxmlformats.org/presentationml/2006/main" xmlns:r="http://schemas.openxmlformats.org/officeDocument/2006/relationships">
+<p:sld xmlns:a="http://schemas.openxmlformats.org/drawingml/2006/main" xmlns:r="http://schemas.openxmlformats.org/officeDocument/2006/relationships" xmlns:p="http://schemas.openxmlformats.org/presentationml/2006/main">
   <p:cSld>
     <p:spTree>
       <p:nvGrpSpPr>
@@ -6761,7 +6860,14 @@
         <p:cNvGrpSpPr/>
         <p:nvPr/>
       </p:nvGrpSpPr>
-      <p:grpSpPr/>
+      <p:grpSpPr>
+        <a:xfrm>
+          <a:off x="0" y="0"/>
+          <a:ext cx="0" cy="0"/>
+          <a:chOff x="0" y="0"/>
+          <a:chExt cx="0" cy="0"/>
+        </a:xfrm>
+      </p:grpSpPr>
       <p:sp>
         <p:nvSpPr>
           <p:cNvPr id="2" name="Rectangle 1"/>
@@ -6803,6 +6909,7 @@
           <a:lstStyle/>
           <a:p>
             <a:pPr algn="ctr"/>
+            <a:endParaRPr/>
           </a:p>
         </p:txBody>
       </p:sp>
@@ -6847,6 +6954,7 @@
           <a:lstStyle/>
           <a:p>
             <a:pPr algn="ctr"/>
+            <a:endParaRPr/>
           </a:p>
         </p:txBody>
       </p:sp>
@@ -6867,7 +6975,7 @@
           <a:noFill/>
         </p:spPr>
         <p:txBody>
-          <a:bodyPr wrap="square" lIns="0" rIns="0" tIns="0" bIns="0" anchor="ctr">
+          <a:bodyPr wrap="square" lIns="0" tIns="0" rIns="0" bIns="0" anchor="ctr">
             <a:spAutoFit/>
           </a:bodyPr>
           <a:lstStyle/>
@@ -6902,7 +7010,7 @@
           <a:noFill/>
         </p:spPr>
         <p:txBody>
-          <a:bodyPr wrap="square" lIns="0" rIns="0" tIns="0" bIns="0">
+          <a:bodyPr wrap="square" lIns="0" tIns="0" rIns="0" bIns="0">
             <a:spAutoFit/>
           </a:bodyPr>
           <a:lstStyle/>
@@ -6941,7 +7049,7 @@
           <a:noFill/>
         </p:spPr>
         <p:txBody>
-          <a:bodyPr wrap="square" lIns="0" rIns="0" tIns="0" bIns="0">
+          <a:bodyPr wrap="square" lIns="0" tIns="0" rIns="0" bIns="0">
             <a:spAutoFit/>
           </a:bodyPr>
           <a:lstStyle/>
@@ -7000,6 +7108,7 @@
           <a:lstStyle/>
           <a:p>
             <a:pPr algn="ctr"/>
+            <a:endParaRPr/>
           </a:p>
         </p:txBody>
       </p:sp>
@@ -7020,7 +7129,7 @@
           <a:noFill/>
         </p:spPr>
         <p:txBody>
-          <a:bodyPr wrap="none" lIns="0" rIns="0" tIns="0" bIns="0">
+          <a:bodyPr wrap="none" lIns="0" tIns="0" rIns="0" bIns="0">
             <a:spAutoFit/>
           </a:bodyPr>
           <a:lstStyle/>
@@ -7147,6 +7256,7 @@
           <a:lstStyle/>
           <a:p>
             <a:pPr algn="ctr"/>
+            <a:endParaRPr/>
           </a:p>
         </p:txBody>
       </p:sp>
@@ -7167,7 +7277,7 @@
           <a:noFill/>
         </p:spPr>
         <p:txBody>
-          <a:bodyPr wrap="square" lIns="0" rIns="0" tIns="0" bIns="0">
+          <a:bodyPr wrap="square" lIns="0" tIns="0" rIns="0" bIns="0">
             <a:spAutoFit/>
           </a:bodyPr>
           <a:lstStyle/>
@@ -7202,7 +7312,7 @@
           <a:noFill/>
         </p:spPr>
         <p:txBody>
-          <a:bodyPr wrap="square" lIns="0" rIns="0" tIns="0" bIns="0">
+          <a:bodyPr wrap="square" lIns="0" tIns="0" rIns="0" bIns="0">
             <a:spAutoFit/>
           </a:bodyPr>
           <a:lstStyle/>
@@ -7273,7 +7383,7 @@
           <a:noFill/>
         </p:spPr>
         <p:txBody>
-          <a:bodyPr wrap="square" lIns="0" rIns="0" tIns="0" bIns="0">
+          <a:bodyPr wrap="square" lIns="0" tIns="0" rIns="0" bIns="0">
             <a:spAutoFit/>
           </a:bodyPr>
           <a:lstStyle/>
@@ -7300,7 +7410,7 @@
 </file>
 
 <file path=ppt/slides/slide17.xml><?xml version="1.0" encoding="utf-8"?>
-<p:sld xmlns:a="http://schemas.openxmlformats.org/drawingml/2006/main" xmlns:p="http://schemas.openxmlformats.org/presentationml/2006/main" xmlns:r="http://schemas.openxmlformats.org/officeDocument/2006/relationships">
+<p:sld xmlns:a="http://schemas.openxmlformats.org/drawingml/2006/main" xmlns:r="http://schemas.openxmlformats.org/officeDocument/2006/relationships" xmlns:p="http://schemas.openxmlformats.org/presentationml/2006/main">
   <p:cSld>
     <p:spTree>
       <p:nvGrpSpPr>
@@ -7308,7 +7418,14 @@
         <p:cNvGrpSpPr/>
         <p:nvPr/>
       </p:nvGrpSpPr>
-      <p:grpSpPr/>
+      <p:grpSpPr>
+        <a:xfrm>
+          <a:off x="0" y="0"/>
+          <a:ext cx="0" cy="0"/>
+          <a:chOff x="0" y="0"/>
+          <a:chExt cx="0" cy="0"/>
+        </a:xfrm>
+      </p:grpSpPr>
       <p:sp>
         <p:nvSpPr>
           <p:cNvPr id="2" name="Rectangle 1"/>
@@ -7350,6 +7467,7 @@
           <a:lstStyle/>
           <a:p>
             <a:pPr algn="ctr"/>
+            <a:endParaRPr/>
           </a:p>
         </p:txBody>
       </p:sp>
@@ -7394,6 +7512,7 @@
           <a:lstStyle/>
           <a:p>
             <a:pPr algn="ctr"/>
+            <a:endParaRPr/>
           </a:p>
         </p:txBody>
       </p:sp>
@@ -7414,7 +7533,7 @@
           <a:noFill/>
         </p:spPr>
         <p:txBody>
-          <a:bodyPr wrap="square" lIns="0" rIns="0" tIns="0" bIns="0" anchor="ctr">
+          <a:bodyPr wrap="square" lIns="0" tIns="0" rIns="0" bIns="0" anchor="ctr">
             <a:spAutoFit/>
           </a:bodyPr>
           <a:lstStyle/>
@@ -7449,7 +7568,7 @@
           <a:noFill/>
         </p:spPr>
         <p:txBody>
-          <a:bodyPr wrap="square" lIns="0" rIns="0" tIns="0" bIns="0">
+          <a:bodyPr wrap="square" lIns="0" tIns="0" rIns="0" bIns="0">
             <a:spAutoFit/>
           </a:bodyPr>
           <a:lstStyle/>
@@ -7488,7 +7607,7 @@
           <a:noFill/>
         </p:spPr>
         <p:txBody>
-          <a:bodyPr wrap="square" lIns="0" rIns="0" tIns="0" bIns="0">
+          <a:bodyPr wrap="square" lIns="0" tIns="0" rIns="0" bIns="0">
             <a:spAutoFit/>
           </a:bodyPr>
           <a:lstStyle/>
@@ -7547,6 +7666,7 @@
           <a:lstStyle/>
           <a:p>
             <a:pPr algn="ctr"/>
+            <a:endParaRPr/>
           </a:p>
         </p:txBody>
       </p:sp>
@@ -7567,7 +7687,7 @@
           <a:noFill/>
         </p:spPr>
         <p:txBody>
-          <a:bodyPr wrap="none" lIns="0" rIns="0" tIns="0" bIns="0">
+          <a:bodyPr wrap="none" lIns="0" tIns="0" rIns="0" bIns="0">
             <a:spAutoFit/>
           </a:bodyPr>
           <a:lstStyle/>
@@ -7710,6 +7830,7 @@
           <a:lstStyle/>
           <a:p>
             <a:pPr algn="ctr"/>
+            <a:endParaRPr/>
           </a:p>
         </p:txBody>
       </p:sp>
@@ -7730,7 +7851,7 @@
           <a:noFill/>
         </p:spPr>
         <p:txBody>
-          <a:bodyPr wrap="square" lIns="0" rIns="0" tIns="0" bIns="0">
+          <a:bodyPr wrap="square" lIns="0" tIns="0" rIns="0" bIns="0">
             <a:spAutoFit/>
           </a:bodyPr>
           <a:lstStyle/>
@@ -7765,7 +7886,7 @@
           <a:noFill/>
         </p:spPr>
         <p:txBody>
-          <a:bodyPr wrap="square" lIns="0" rIns="0" tIns="0" bIns="0">
+          <a:bodyPr wrap="square" lIns="0" tIns="0" rIns="0" bIns="0">
             <a:spAutoFit/>
           </a:bodyPr>
           <a:lstStyle/>
@@ -7836,7 +7957,7 @@
           <a:noFill/>
         </p:spPr>
         <p:txBody>
-          <a:bodyPr wrap="square" lIns="0" rIns="0" tIns="0" bIns="0">
+          <a:bodyPr wrap="square" lIns="0" tIns="0" rIns="0" bIns="0">
             <a:spAutoFit/>
           </a:bodyPr>
           <a:lstStyle/>
@@ -7863,7 +7984,7 @@
 </file>
 
 <file path=ppt/slides/slide18.xml><?xml version="1.0" encoding="utf-8"?>
-<p:sld xmlns:a="http://schemas.openxmlformats.org/drawingml/2006/main" xmlns:p="http://schemas.openxmlformats.org/presentationml/2006/main" xmlns:r="http://schemas.openxmlformats.org/officeDocument/2006/relationships">
+<p:sld xmlns:a="http://schemas.openxmlformats.org/drawingml/2006/main" xmlns:r="http://schemas.openxmlformats.org/officeDocument/2006/relationships" xmlns:p="http://schemas.openxmlformats.org/presentationml/2006/main">
   <p:cSld>
     <p:spTree>
       <p:nvGrpSpPr>
@@ -7871,7 +7992,14 @@
         <p:cNvGrpSpPr/>
         <p:nvPr/>
       </p:nvGrpSpPr>
-      <p:grpSpPr/>
+      <p:grpSpPr>
+        <a:xfrm>
+          <a:off x="0" y="0"/>
+          <a:ext cx="0" cy="0"/>
+          <a:chOff x="0" y="0"/>
+          <a:chExt cx="0" cy="0"/>
+        </a:xfrm>
+      </p:grpSpPr>
       <p:sp>
         <p:nvSpPr>
           <p:cNvPr id="2" name="Rectangle 1"/>
@@ -7913,6 +8041,7 @@
           <a:lstStyle/>
           <a:p>
             <a:pPr algn="ctr"/>
+            <a:endParaRPr/>
           </a:p>
         </p:txBody>
       </p:sp>
@@ -7957,6 +8086,7 @@
           <a:lstStyle/>
           <a:p>
             <a:pPr algn="ctr"/>
+            <a:endParaRPr/>
           </a:p>
         </p:txBody>
       </p:sp>
@@ -7977,7 +8107,7 @@
           <a:noFill/>
         </p:spPr>
         <p:txBody>
-          <a:bodyPr wrap="square" lIns="0" rIns="0" tIns="0" bIns="0" anchor="ctr">
+          <a:bodyPr wrap="square" lIns="0" tIns="0" rIns="0" bIns="0" anchor="ctr">
             <a:spAutoFit/>
           </a:bodyPr>
           <a:lstStyle/>
@@ -8036,6 +8166,7 @@
           <a:lstStyle/>
           <a:p>
             <a:pPr algn="ctr"/>
+            <a:endParaRPr/>
           </a:p>
         </p:txBody>
       </p:sp>
@@ -8056,7 +8187,7 @@
           <a:noFill/>
         </p:spPr>
         <p:txBody>
-          <a:bodyPr wrap="square" lIns="0" rIns="0" tIns="0" bIns="0">
+          <a:bodyPr wrap="square" lIns="0" tIns="0" rIns="0" bIns="0">
             <a:spAutoFit/>
           </a:bodyPr>
           <a:lstStyle/>
@@ -8091,7 +8222,7 @@
           <a:noFill/>
         </p:spPr>
         <p:txBody>
-          <a:bodyPr wrap="square" lIns="0" rIns="0" tIns="0" bIns="0">
+          <a:bodyPr wrap="square" lIns="0" tIns="0" rIns="0" bIns="0">
             <a:spAutoFit/>
           </a:bodyPr>
           <a:lstStyle/>
@@ -8194,7 +8325,7 @@
           <a:noFill/>
         </p:spPr>
         <p:txBody>
-          <a:bodyPr wrap="square" lIns="0" rIns="0" tIns="0" bIns="0">
+          <a:bodyPr wrap="square" lIns="0" tIns="0" rIns="0" bIns="0">
             <a:spAutoFit/>
           </a:bodyPr>
           <a:lstStyle/>
@@ -8221,7 +8352,7 @@
 </file>
 
 <file path=ppt/slides/slide19.xml><?xml version="1.0" encoding="utf-8"?>
-<p:sld xmlns:a="http://schemas.openxmlformats.org/drawingml/2006/main" xmlns:p="http://schemas.openxmlformats.org/presentationml/2006/main" xmlns:r="http://schemas.openxmlformats.org/officeDocument/2006/relationships">
+<p:sld xmlns:a="http://schemas.openxmlformats.org/drawingml/2006/main" xmlns:r="http://schemas.openxmlformats.org/officeDocument/2006/relationships" xmlns:p="http://schemas.openxmlformats.org/presentationml/2006/main">
   <p:cSld>
     <p:spTree>
       <p:nvGrpSpPr>
@@ -8229,7 +8360,14 @@
         <p:cNvGrpSpPr/>
         <p:nvPr/>
       </p:nvGrpSpPr>
-      <p:grpSpPr/>
+      <p:grpSpPr>
+        <a:xfrm>
+          <a:off x="0" y="0"/>
+          <a:ext cx="0" cy="0"/>
+          <a:chOff x="0" y="0"/>
+          <a:chExt cx="0" cy="0"/>
+        </a:xfrm>
+      </p:grpSpPr>
       <p:sp>
         <p:nvSpPr>
           <p:cNvPr id="2" name="Rectangle 1"/>
@@ -8271,6 +8409,7 @@
           <a:lstStyle/>
           <a:p>
             <a:pPr algn="ctr"/>
+            <a:endParaRPr/>
           </a:p>
         </p:txBody>
       </p:sp>
@@ -8315,6 +8454,7 @@
           <a:lstStyle/>
           <a:p>
             <a:pPr algn="ctr"/>
+            <a:endParaRPr/>
           </a:p>
         </p:txBody>
       </p:sp>
@@ -8335,7 +8475,7 @@
           <a:noFill/>
         </p:spPr>
         <p:txBody>
-          <a:bodyPr wrap="square" lIns="0" rIns="0" tIns="0" bIns="0" anchor="ctr">
+          <a:bodyPr wrap="square" lIns="0" tIns="0" rIns="0" bIns="0" anchor="ctr">
             <a:spAutoFit/>
           </a:bodyPr>
           <a:lstStyle/>
@@ -8394,6 +8534,7 @@
           <a:lstStyle/>
           <a:p>
             <a:pPr algn="ctr"/>
+            <a:endParaRPr/>
           </a:p>
         </p:txBody>
       </p:sp>
@@ -8414,7 +8555,7 @@
           <a:noFill/>
         </p:spPr>
         <p:txBody>
-          <a:bodyPr wrap="square" lIns="0" rIns="0" tIns="0" bIns="0">
+          <a:bodyPr wrap="square" lIns="0" tIns="0" rIns="0" bIns="0">
             <a:spAutoFit/>
           </a:bodyPr>
           <a:lstStyle/>
@@ -8473,6 +8614,7 @@
           <a:lstStyle/>
           <a:p>
             <a:pPr algn="ctr"/>
+            <a:endParaRPr/>
           </a:p>
         </p:txBody>
       </p:sp>
@@ -8493,7 +8635,7 @@
           <a:noFill/>
         </p:spPr>
         <p:txBody>
-          <a:bodyPr wrap="square" lIns="0" rIns="0" tIns="0" bIns="0" anchor="ctr">
+          <a:bodyPr wrap="square" lIns="0" tIns="0" rIns="0" bIns="0" anchor="ctr">
             <a:spAutoFit/>
           </a:bodyPr>
           <a:lstStyle/>
@@ -8520,7 +8662,7 @@
 </file>
 
 <file path=ppt/slides/slide2.xml><?xml version="1.0" encoding="utf-8"?>
-<p:sld xmlns:a="http://schemas.openxmlformats.org/drawingml/2006/main" xmlns:p="http://schemas.openxmlformats.org/presentationml/2006/main" xmlns:r="http://schemas.openxmlformats.org/officeDocument/2006/relationships">
+<p:sld xmlns:a="http://schemas.openxmlformats.org/drawingml/2006/main" xmlns:r="http://schemas.openxmlformats.org/officeDocument/2006/relationships" xmlns:p="http://schemas.openxmlformats.org/presentationml/2006/main">
   <p:cSld>
     <p:spTree>
       <p:nvGrpSpPr>
@@ -8528,7 +8670,14 @@
         <p:cNvGrpSpPr/>
         <p:nvPr/>
       </p:nvGrpSpPr>
-      <p:grpSpPr/>
+      <p:grpSpPr>
+        <a:xfrm>
+          <a:off x="0" y="0"/>
+          <a:ext cx="0" cy="0"/>
+          <a:chOff x="0" y="0"/>
+          <a:chExt cx="0" cy="0"/>
+        </a:xfrm>
+      </p:grpSpPr>
       <p:sp>
         <p:nvSpPr>
           <p:cNvPr id="2" name="Rectangle 1"/>
@@ -8570,6 +8719,7 @@
           <a:lstStyle/>
           <a:p>
             <a:pPr algn="ctr"/>
+            <a:endParaRPr/>
           </a:p>
         </p:txBody>
       </p:sp>
@@ -8614,6 +8764,7 @@
           <a:lstStyle/>
           <a:p>
             <a:pPr algn="ctr"/>
+            <a:endParaRPr/>
           </a:p>
         </p:txBody>
       </p:sp>
@@ -8634,7 +8785,7 @@
           <a:noFill/>
         </p:spPr>
         <p:txBody>
-          <a:bodyPr wrap="square" lIns="0" rIns="0" tIns="0" bIns="0" anchor="ctr">
+          <a:bodyPr wrap="square" lIns="0" tIns="0" rIns="0" bIns="0" anchor="ctr">
             <a:spAutoFit/>
           </a:bodyPr>
           <a:lstStyle/>
@@ -8669,7 +8820,7 @@
           <a:noFill/>
         </p:spPr>
         <p:txBody>
-          <a:bodyPr wrap="square" lIns="0" rIns="0" tIns="0" bIns="0">
+          <a:bodyPr wrap="square" lIns="0" tIns="0" rIns="0" bIns="0">
             <a:spAutoFit/>
           </a:bodyPr>
           <a:lstStyle/>
@@ -8732,6 +8883,7 @@
           <a:lstStyle/>
           <a:p>
             <a:pPr algn="ctr"/>
+            <a:endParaRPr/>
           </a:p>
         </p:txBody>
       </p:sp>
@@ -8752,7 +8904,7 @@
           <a:noFill/>
         </p:spPr>
         <p:txBody>
-          <a:bodyPr wrap="square" lIns="0" rIns="0" tIns="0" bIns="0">
+          <a:bodyPr wrap="square" lIns="0" tIns="0" rIns="0" bIns="0">
             <a:spAutoFit/>
           </a:bodyPr>
           <a:lstStyle/>
@@ -8787,7 +8939,7 @@
           <a:noFill/>
         </p:spPr>
         <p:txBody>
-          <a:bodyPr wrap="square" lIns="0" rIns="0" tIns="0" bIns="0">
+          <a:bodyPr wrap="square" lIns="0" tIns="0" rIns="0" bIns="0">
             <a:spAutoFit/>
           </a:bodyPr>
           <a:lstStyle/>
@@ -8954,7 +9106,7 @@
           <a:noFill/>
         </p:spPr>
         <p:txBody>
-          <a:bodyPr wrap="square" lIns="0" rIns="0" tIns="0" bIns="0">
+          <a:bodyPr wrap="square" lIns="0" tIns="0" rIns="0" bIns="0">
             <a:spAutoFit/>
           </a:bodyPr>
           <a:lstStyle/>
@@ -8981,7 +9133,7 @@
 </file>
 
 <file path=ppt/slides/slide3.xml><?xml version="1.0" encoding="utf-8"?>
-<p:sld xmlns:a="http://schemas.openxmlformats.org/drawingml/2006/main" xmlns:p="http://schemas.openxmlformats.org/presentationml/2006/main" xmlns:r="http://schemas.openxmlformats.org/officeDocument/2006/relationships">
+<p:sld xmlns:a="http://schemas.openxmlformats.org/drawingml/2006/main" xmlns:r="http://schemas.openxmlformats.org/officeDocument/2006/relationships" xmlns:p="http://schemas.openxmlformats.org/presentationml/2006/main">
   <p:cSld>
     <p:spTree>
       <p:nvGrpSpPr>
@@ -8989,7 +9141,14 @@
         <p:cNvGrpSpPr/>
         <p:nvPr/>
       </p:nvGrpSpPr>
-      <p:grpSpPr/>
+      <p:grpSpPr>
+        <a:xfrm>
+          <a:off x="0" y="0"/>
+          <a:ext cx="0" cy="0"/>
+          <a:chOff x="0" y="0"/>
+          <a:chExt cx="0" cy="0"/>
+        </a:xfrm>
+      </p:grpSpPr>
       <p:sp>
         <p:nvSpPr>
           <p:cNvPr id="2" name="Rectangle 1"/>
@@ -9031,6 +9190,7 @@
           <a:lstStyle/>
           <a:p>
             <a:pPr algn="ctr"/>
+            <a:endParaRPr/>
           </a:p>
         </p:txBody>
       </p:sp>
@@ -9075,6 +9235,7 @@
           <a:lstStyle/>
           <a:p>
             <a:pPr algn="ctr"/>
+            <a:endParaRPr/>
           </a:p>
         </p:txBody>
       </p:sp>
@@ -9095,7 +9256,7 @@
           <a:noFill/>
         </p:spPr>
         <p:txBody>
-          <a:bodyPr wrap="square" lIns="0" rIns="0" tIns="0" bIns="0" anchor="ctr">
+          <a:bodyPr wrap="square" lIns="0" tIns="0" rIns="0" bIns="0" anchor="ctr">
             <a:spAutoFit/>
           </a:bodyPr>
           <a:lstStyle/>
@@ -9130,7 +9291,7 @@
           <a:noFill/>
         </p:spPr>
         <p:txBody>
-          <a:bodyPr wrap="square" lIns="0" rIns="0" tIns="0" bIns="0">
+          <a:bodyPr wrap="square" lIns="0" tIns="0" rIns="0" bIns="0">
             <a:spAutoFit/>
           </a:bodyPr>
           <a:lstStyle/>
@@ -9169,7 +9330,7 @@
           <a:noFill/>
         </p:spPr>
         <p:txBody>
-          <a:bodyPr wrap="square" lIns="0" rIns="0" tIns="0" bIns="0">
+          <a:bodyPr wrap="square" lIns="0" tIns="0" rIns="0" bIns="0">
             <a:spAutoFit/>
           </a:bodyPr>
           <a:lstStyle/>
@@ -9228,6 +9389,7 @@
           <a:lstStyle/>
           <a:p>
             <a:pPr algn="ctr"/>
+            <a:endParaRPr/>
           </a:p>
         </p:txBody>
       </p:sp>
@@ -9248,7 +9410,7 @@
           <a:noFill/>
         </p:spPr>
         <p:txBody>
-          <a:bodyPr wrap="none" lIns="0" rIns="0" tIns="0" bIns="0">
+          <a:bodyPr wrap="none" lIns="0" tIns="0" rIns="0" bIns="0">
             <a:spAutoFit/>
           </a:bodyPr>
           <a:lstStyle/>
@@ -9391,6 +9553,7 @@
           <a:lstStyle/>
           <a:p>
             <a:pPr algn="ctr"/>
+            <a:endParaRPr/>
           </a:p>
         </p:txBody>
       </p:sp>
@@ -9411,7 +9574,7 @@
           <a:noFill/>
         </p:spPr>
         <p:txBody>
-          <a:bodyPr wrap="square" lIns="0" rIns="0" tIns="0" bIns="0">
+          <a:bodyPr wrap="square" lIns="0" tIns="0" rIns="0" bIns="0">
             <a:spAutoFit/>
           </a:bodyPr>
           <a:lstStyle/>
@@ -9446,7 +9609,7 @@
           <a:noFill/>
         </p:spPr>
         <p:txBody>
-          <a:bodyPr wrap="square" lIns="0" rIns="0" tIns="0" bIns="0">
+          <a:bodyPr wrap="square" lIns="0" tIns="0" rIns="0" bIns="0">
             <a:spAutoFit/>
           </a:bodyPr>
           <a:lstStyle/>
@@ -9517,7 +9680,7 @@
           <a:noFill/>
         </p:spPr>
         <p:txBody>
-          <a:bodyPr wrap="square" lIns="0" rIns="0" tIns="0" bIns="0">
+          <a:bodyPr wrap="square" lIns="0" tIns="0" rIns="0" bIns="0">
             <a:spAutoFit/>
           </a:bodyPr>
           <a:lstStyle/>
@@ -9544,7 +9707,7 @@
 </file>
 
 <file path=ppt/slides/slide4.xml><?xml version="1.0" encoding="utf-8"?>
-<p:sld xmlns:a="http://schemas.openxmlformats.org/drawingml/2006/main" xmlns:p="http://schemas.openxmlformats.org/presentationml/2006/main" xmlns:r="http://schemas.openxmlformats.org/officeDocument/2006/relationships">
+<p:sld xmlns:a="http://schemas.openxmlformats.org/drawingml/2006/main" xmlns:r="http://schemas.openxmlformats.org/officeDocument/2006/relationships" xmlns:p="http://schemas.openxmlformats.org/presentationml/2006/main">
   <p:cSld>
     <p:spTree>
       <p:nvGrpSpPr>
@@ -9552,7 +9715,14 @@
         <p:cNvGrpSpPr/>
         <p:nvPr/>
       </p:nvGrpSpPr>
-      <p:grpSpPr/>
+      <p:grpSpPr>
+        <a:xfrm>
+          <a:off x="0" y="0"/>
+          <a:ext cx="0" cy="0"/>
+          <a:chOff x="0" y="0"/>
+          <a:chExt cx="0" cy="0"/>
+        </a:xfrm>
+      </p:grpSpPr>
       <p:sp>
         <p:nvSpPr>
           <p:cNvPr id="2" name="Rectangle 1"/>
@@ -9594,6 +9764,7 @@
           <a:lstStyle/>
           <a:p>
             <a:pPr algn="ctr"/>
+            <a:endParaRPr/>
           </a:p>
         </p:txBody>
       </p:sp>
@@ -9638,6 +9809,7 @@
           <a:lstStyle/>
           <a:p>
             <a:pPr algn="ctr"/>
+            <a:endParaRPr/>
           </a:p>
         </p:txBody>
       </p:sp>
@@ -9658,7 +9830,7 @@
           <a:noFill/>
         </p:spPr>
         <p:txBody>
-          <a:bodyPr wrap="square" lIns="0" rIns="0" tIns="0" bIns="0" anchor="ctr">
+          <a:bodyPr wrap="square" lIns="0" tIns="0" rIns="0" bIns="0" anchor="ctr">
             <a:spAutoFit/>
           </a:bodyPr>
           <a:lstStyle/>
@@ -9693,7 +9865,7 @@
           <a:noFill/>
         </p:spPr>
         <p:txBody>
-          <a:bodyPr wrap="square" lIns="0" rIns="0" tIns="0" bIns="0">
+          <a:bodyPr wrap="square" lIns="0" tIns="0" rIns="0" bIns="0">
             <a:spAutoFit/>
           </a:bodyPr>
           <a:lstStyle/>
@@ -9732,7 +9904,7 @@
           <a:noFill/>
         </p:spPr>
         <p:txBody>
-          <a:bodyPr wrap="square" lIns="0" rIns="0" tIns="0" bIns="0">
+          <a:bodyPr wrap="square" lIns="0" tIns="0" rIns="0" bIns="0">
             <a:spAutoFit/>
           </a:bodyPr>
           <a:lstStyle/>
@@ -9791,6 +9963,7 @@
           <a:lstStyle/>
           <a:p>
             <a:pPr algn="ctr"/>
+            <a:endParaRPr/>
           </a:p>
         </p:txBody>
       </p:sp>
@@ -9811,7 +9984,7 @@
           <a:noFill/>
         </p:spPr>
         <p:txBody>
-          <a:bodyPr wrap="none" lIns="0" rIns="0" tIns="0" bIns="0">
+          <a:bodyPr wrap="none" lIns="0" tIns="0" rIns="0" bIns="0">
             <a:spAutoFit/>
           </a:bodyPr>
           <a:lstStyle/>
@@ -9906,6 +10079,7 @@
           <a:lstStyle/>
           <a:p>
             <a:pPr algn="ctr"/>
+            <a:endParaRPr/>
           </a:p>
         </p:txBody>
       </p:sp>
@@ -9926,7 +10100,7 @@
           <a:noFill/>
         </p:spPr>
         <p:txBody>
-          <a:bodyPr wrap="square" lIns="0" rIns="0" tIns="0" bIns="0">
+          <a:bodyPr wrap="square" lIns="0" tIns="0" rIns="0" bIns="0">
             <a:spAutoFit/>
           </a:bodyPr>
           <a:lstStyle/>
@@ -9961,7 +10135,7 @@
           <a:noFill/>
         </p:spPr>
         <p:txBody>
-          <a:bodyPr wrap="square" lIns="0" rIns="0" tIns="0" bIns="0">
+          <a:bodyPr wrap="square" lIns="0" tIns="0" rIns="0" bIns="0">
             <a:spAutoFit/>
           </a:bodyPr>
           <a:lstStyle/>
@@ -10032,7 +10206,7 @@
           <a:noFill/>
         </p:spPr>
         <p:txBody>
-          <a:bodyPr wrap="square" lIns="0" rIns="0" tIns="0" bIns="0">
+          <a:bodyPr wrap="square" lIns="0" tIns="0" rIns="0" bIns="0">
             <a:spAutoFit/>
           </a:bodyPr>
           <a:lstStyle/>
@@ -10059,7 +10233,7 @@
 </file>
 
 <file path=ppt/slides/slide5.xml><?xml version="1.0" encoding="utf-8"?>
-<p:sld xmlns:a="http://schemas.openxmlformats.org/drawingml/2006/main" xmlns:p="http://schemas.openxmlformats.org/presentationml/2006/main" xmlns:r="http://schemas.openxmlformats.org/officeDocument/2006/relationships">
+<p:sld xmlns:a="http://schemas.openxmlformats.org/drawingml/2006/main" xmlns:r="http://schemas.openxmlformats.org/officeDocument/2006/relationships" xmlns:p="http://schemas.openxmlformats.org/presentationml/2006/main">
   <p:cSld>
     <p:spTree>
       <p:nvGrpSpPr>
@@ -10067,7 +10241,14 @@
         <p:cNvGrpSpPr/>
         <p:nvPr/>
       </p:nvGrpSpPr>
-      <p:grpSpPr/>
+      <p:grpSpPr>
+        <a:xfrm>
+          <a:off x="0" y="0"/>
+          <a:ext cx="0" cy="0"/>
+          <a:chOff x="0" y="0"/>
+          <a:chExt cx="0" cy="0"/>
+        </a:xfrm>
+      </p:grpSpPr>
       <p:sp>
         <p:nvSpPr>
           <p:cNvPr id="2" name="Rectangle 1"/>
@@ -10109,6 +10290,7 @@
           <a:lstStyle/>
           <a:p>
             <a:pPr algn="ctr"/>
+            <a:endParaRPr/>
           </a:p>
         </p:txBody>
       </p:sp>
@@ -10153,6 +10335,7 @@
           <a:lstStyle/>
           <a:p>
             <a:pPr algn="ctr"/>
+            <a:endParaRPr/>
           </a:p>
         </p:txBody>
       </p:sp>
@@ -10173,7 +10356,7 @@
           <a:noFill/>
         </p:spPr>
         <p:txBody>
-          <a:bodyPr wrap="square" lIns="0" rIns="0" tIns="0" bIns="0" anchor="ctr">
+          <a:bodyPr wrap="square" lIns="0" tIns="0" rIns="0" bIns="0" anchor="ctr">
             <a:spAutoFit/>
           </a:bodyPr>
           <a:lstStyle/>
@@ -10208,7 +10391,7 @@
           <a:noFill/>
         </p:spPr>
         <p:txBody>
-          <a:bodyPr wrap="square" lIns="0" rIns="0" tIns="0" bIns="0">
+          <a:bodyPr wrap="square" lIns="0" tIns="0" rIns="0" bIns="0">
             <a:spAutoFit/>
           </a:bodyPr>
           <a:lstStyle/>
@@ -10247,7 +10430,7 @@
           <a:noFill/>
         </p:spPr>
         <p:txBody>
-          <a:bodyPr wrap="square" lIns="0" rIns="0" tIns="0" bIns="0">
+          <a:bodyPr wrap="square" lIns="0" tIns="0" rIns="0" bIns="0">
             <a:spAutoFit/>
           </a:bodyPr>
           <a:lstStyle/>
@@ -10306,6 +10489,7 @@
           <a:lstStyle/>
           <a:p>
             <a:pPr algn="ctr"/>
+            <a:endParaRPr/>
           </a:p>
         </p:txBody>
       </p:sp>
@@ -10326,7 +10510,7 @@
           <a:noFill/>
         </p:spPr>
         <p:txBody>
-          <a:bodyPr wrap="none" lIns="0" rIns="0" tIns="0" bIns="0">
+          <a:bodyPr wrap="none" lIns="0" tIns="0" rIns="0" bIns="0">
             <a:spAutoFit/>
           </a:bodyPr>
           <a:lstStyle/>
@@ -10389,6 +10573,7 @@
           <a:lstStyle/>
           <a:p>
             <a:pPr algn="ctr"/>
+            <a:endParaRPr/>
           </a:p>
         </p:txBody>
       </p:sp>
@@ -10409,7 +10594,7 @@
           <a:noFill/>
         </p:spPr>
         <p:txBody>
-          <a:bodyPr wrap="square" lIns="0" rIns="0" tIns="0" bIns="0">
+          <a:bodyPr wrap="square" lIns="0" tIns="0" rIns="0" bIns="0">
             <a:spAutoFit/>
           </a:bodyPr>
           <a:lstStyle/>
@@ -10444,7 +10629,7 @@
           <a:noFill/>
         </p:spPr>
         <p:txBody>
-          <a:bodyPr wrap="square" lIns="0" rIns="0" tIns="0" bIns="0">
+          <a:bodyPr wrap="square" lIns="0" tIns="0" rIns="0" bIns="0">
             <a:spAutoFit/>
           </a:bodyPr>
           <a:lstStyle/>
@@ -10515,7 +10700,7 @@
           <a:noFill/>
         </p:spPr>
         <p:txBody>
-          <a:bodyPr wrap="square" lIns="0" rIns="0" tIns="0" bIns="0">
+          <a:bodyPr wrap="square" lIns="0" tIns="0" rIns="0" bIns="0">
             <a:spAutoFit/>
           </a:bodyPr>
           <a:lstStyle/>
@@ -10542,7 +10727,7 @@
 </file>
 
 <file path=ppt/slides/slide6.xml><?xml version="1.0" encoding="utf-8"?>
-<p:sld xmlns:a="http://schemas.openxmlformats.org/drawingml/2006/main" xmlns:p="http://schemas.openxmlformats.org/presentationml/2006/main" xmlns:r="http://schemas.openxmlformats.org/officeDocument/2006/relationships">
+<p:sld xmlns:a="http://schemas.openxmlformats.org/drawingml/2006/main" xmlns:r="http://schemas.openxmlformats.org/officeDocument/2006/relationships" xmlns:p="http://schemas.openxmlformats.org/presentationml/2006/main">
   <p:cSld>
     <p:spTree>
       <p:nvGrpSpPr>
@@ -10550,7 +10735,14 @@
         <p:cNvGrpSpPr/>
         <p:nvPr/>
       </p:nvGrpSpPr>
-      <p:grpSpPr/>
+      <p:grpSpPr>
+        <a:xfrm>
+          <a:off x="0" y="0"/>
+          <a:ext cx="0" cy="0"/>
+          <a:chOff x="0" y="0"/>
+          <a:chExt cx="0" cy="0"/>
+        </a:xfrm>
+      </p:grpSpPr>
       <p:sp>
         <p:nvSpPr>
           <p:cNvPr id="2" name="Rectangle 1"/>
@@ -10592,6 +10784,7 @@
           <a:lstStyle/>
           <a:p>
             <a:pPr algn="ctr"/>
+            <a:endParaRPr/>
           </a:p>
         </p:txBody>
       </p:sp>
@@ -10636,6 +10829,7 @@
           <a:lstStyle/>
           <a:p>
             <a:pPr algn="ctr"/>
+            <a:endParaRPr/>
           </a:p>
         </p:txBody>
       </p:sp>
@@ -10656,7 +10850,7 @@
           <a:noFill/>
         </p:spPr>
         <p:txBody>
-          <a:bodyPr wrap="square" lIns="0" rIns="0" tIns="0" bIns="0" anchor="ctr">
+          <a:bodyPr wrap="square" lIns="0" tIns="0" rIns="0" bIns="0" anchor="ctr">
             <a:spAutoFit/>
           </a:bodyPr>
           <a:lstStyle/>
@@ -10691,7 +10885,7 @@
           <a:noFill/>
         </p:spPr>
         <p:txBody>
-          <a:bodyPr wrap="square" lIns="0" rIns="0" tIns="0" bIns="0">
+          <a:bodyPr wrap="square" lIns="0" tIns="0" rIns="0" bIns="0">
             <a:spAutoFit/>
           </a:bodyPr>
           <a:lstStyle/>
@@ -10730,7 +10924,7 @@
           <a:noFill/>
         </p:spPr>
         <p:txBody>
-          <a:bodyPr wrap="square" lIns="0" rIns="0" tIns="0" bIns="0">
+          <a:bodyPr wrap="square" lIns="0" tIns="0" rIns="0" bIns="0">
             <a:spAutoFit/>
           </a:bodyPr>
           <a:lstStyle/>
@@ -10789,6 +10983,7 @@
           <a:lstStyle/>
           <a:p>
             <a:pPr algn="ctr"/>
+            <a:endParaRPr/>
           </a:p>
         </p:txBody>
       </p:sp>
@@ -10809,7 +11004,7 @@
           <a:noFill/>
         </p:spPr>
         <p:txBody>
-          <a:bodyPr wrap="none" lIns="0" rIns="0" tIns="0" bIns="0">
+          <a:bodyPr wrap="none" lIns="0" tIns="0" rIns="0" bIns="0">
             <a:spAutoFit/>
           </a:bodyPr>
           <a:lstStyle/>
@@ -10872,6 +11067,7 @@
           <a:lstStyle/>
           <a:p>
             <a:pPr algn="ctr"/>
+            <a:endParaRPr/>
           </a:p>
         </p:txBody>
       </p:sp>
@@ -10892,7 +11088,7 @@
           <a:noFill/>
         </p:spPr>
         <p:txBody>
-          <a:bodyPr wrap="square" lIns="0" rIns="0" tIns="0" bIns="0">
+          <a:bodyPr wrap="square" lIns="0" tIns="0" rIns="0" bIns="0">
             <a:spAutoFit/>
           </a:bodyPr>
           <a:lstStyle/>
@@ -10927,7 +11123,7 @@
           <a:noFill/>
         </p:spPr>
         <p:txBody>
-          <a:bodyPr wrap="square" lIns="0" rIns="0" tIns="0" bIns="0">
+          <a:bodyPr wrap="square" lIns="0" tIns="0" rIns="0" bIns="0">
             <a:spAutoFit/>
           </a:bodyPr>
           <a:lstStyle/>
@@ -10998,7 +11194,7 @@
           <a:noFill/>
         </p:spPr>
         <p:txBody>
-          <a:bodyPr wrap="square" lIns="0" rIns="0" tIns="0" bIns="0">
+          <a:bodyPr wrap="square" lIns="0" tIns="0" rIns="0" bIns="0">
             <a:spAutoFit/>
           </a:bodyPr>
           <a:lstStyle/>
@@ -11025,7 +11221,7 @@
 </file>
 
 <file path=ppt/slides/slide7.xml><?xml version="1.0" encoding="utf-8"?>
-<p:sld xmlns:a="http://schemas.openxmlformats.org/drawingml/2006/main" xmlns:p="http://schemas.openxmlformats.org/presentationml/2006/main" xmlns:r="http://schemas.openxmlformats.org/officeDocument/2006/relationships">
+<p:sld xmlns:a="http://schemas.openxmlformats.org/drawingml/2006/main" xmlns:r="http://schemas.openxmlformats.org/officeDocument/2006/relationships" xmlns:p="http://schemas.openxmlformats.org/presentationml/2006/main">
   <p:cSld>
     <p:spTree>
       <p:nvGrpSpPr>
@@ -11033,7 +11229,14 @@
         <p:cNvGrpSpPr/>
         <p:nvPr/>
       </p:nvGrpSpPr>
-      <p:grpSpPr/>
+      <p:grpSpPr>
+        <a:xfrm>
+          <a:off x="0" y="0"/>
+          <a:ext cx="0" cy="0"/>
+          <a:chOff x="0" y="0"/>
+          <a:chExt cx="0" cy="0"/>
+        </a:xfrm>
+      </p:grpSpPr>
       <p:sp>
         <p:nvSpPr>
           <p:cNvPr id="2" name="Rectangle 1"/>
@@ -11075,6 +11278,7 @@
           <a:lstStyle/>
           <a:p>
             <a:pPr algn="ctr"/>
+            <a:endParaRPr/>
           </a:p>
         </p:txBody>
       </p:sp>
@@ -11119,6 +11323,7 @@
           <a:lstStyle/>
           <a:p>
             <a:pPr algn="ctr"/>
+            <a:endParaRPr/>
           </a:p>
         </p:txBody>
       </p:sp>
@@ -11139,7 +11344,7 @@
           <a:noFill/>
         </p:spPr>
         <p:txBody>
-          <a:bodyPr wrap="square" lIns="0" rIns="0" tIns="0" bIns="0" anchor="ctr">
+          <a:bodyPr wrap="square" lIns="0" tIns="0" rIns="0" bIns="0" anchor="ctr">
             <a:spAutoFit/>
           </a:bodyPr>
           <a:lstStyle/>
@@ -11174,7 +11379,7 @@
           <a:noFill/>
         </p:spPr>
         <p:txBody>
-          <a:bodyPr wrap="square" lIns="0" rIns="0" tIns="0" bIns="0">
+          <a:bodyPr wrap="square" lIns="0" tIns="0" rIns="0" bIns="0">
             <a:spAutoFit/>
           </a:bodyPr>
           <a:lstStyle/>
@@ -11213,7 +11418,7 @@
           <a:noFill/>
         </p:spPr>
         <p:txBody>
-          <a:bodyPr wrap="square" lIns="0" rIns="0" tIns="0" bIns="0">
+          <a:bodyPr wrap="square" lIns="0" tIns="0" rIns="0" bIns="0">
             <a:spAutoFit/>
           </a:bodyPr>
           <a:lstStyle/>
@@ -11272,6 +11477,7 @@
           <a:lstStyle/>
           <a:p>
             <a:pPr algn="ctr"/>
+            <a:endParaRPr/>
           </a:p>
         </p:txBody>
       </p:sp>
@@ -11292,7 +11498,7 @@
           <a:noFill/>
         </p:spPr>
         <p:txBody>
-          <a:bodyPr wrap="none" lIns="0" rIns="0" tIns="0" bIns="0">
+          <a:bodyPr wrap="none" lIns="0" tIns="0" rIns="0" bIns="0">
             <a:spAutoFit/>
           </a:bodyPr>
           <a:lstStyle/>
@@ -11467,6 +11673,7 @@
           <a:lstStyle/>
           <a:p>
             <a:pPr algn="ctr"/>
+            <a:endParaRPr/>
           </a:p>
         </p:txBody>
       </p:sp>
@@ -11487,7 +11694,7 @@
           <a:noFill/>
         </p:spPr>
         <p:txBody>
-          <a:bodyPr wrap="square" lIns="0" rIns="0" tIns="0" bIns="0">
+          <a:bodyPr wrap="square" lIns="0" tIns="0" rIns="0" bIns="0">
             <a:spAutoFit/>
           </a:bodyPr>
           <a:lstStyle/>
@@ -11522,7 +11729,7 @@
           <a:noFill/>
         </p:spPr>
         <p:txBody>
-          <a:bodyPr wrap="square" lIns="0" rIns="0" tIns="0" bIns="0">
+          <a:bodyPr wrap="square" lIns="0" tIns="0" rIns="0" bIns="0">
             <a:spAutoFit/>
           </a:bodyPr>
           <a:lstStyle/>
@@ -11593,7 +11800,7 @@
           <a:noFill/>
         </p:spPr>
         <p:txBody>
-          <a:bodyPr wrap="square" lIns="0" rIns="0" tIns="0" bIns="0">
+          <a:bodyPr wrap="square" lIns="0" tIns="0" rIns="0" bIns="0">
             <a:spAutoFit/>
           </a:bodyPr>
           <a:lstStyle/>
@@ -11620,7 +11827,7 @@
 </file>
 
 <file path=ppt/slides/slide8.xml><?xml version="1.0" encoding="utf-8"?>
-<p:sld xmlns:a="http://schemas.openxmlformats.org/drawingml/2006/main" xmlns:p="http://schemas.openxmlformats.org/presentationml/2006/main" xmlns:r="http://schemas.openxmlformats.org/officeDocument/2006/relationships">
+<p:sld xmlns:a="http://schemas.openxmlformats.org/drawingml/2006/main" xmlns:r="http://schemas.openxmlformats.org/officeDocument/2006/relationships" xmlns:p="http://schemas.openxmlformats.org/presentationml/2006/main">
   <p:cSld>
     <p:spTree>
       <p:nvGrpSpPr>
@@ -11628,7 +11835,14 @@
         <p:cNvGrpSpPr/>
         <p:nvPr/>
       </p:nvGrpSpPr>
-      <p:grpSpPr/>
+      <p:grpSpPr>
+        <a:xfrm>
+          <a:off x="0" y="0"/>
+          <a:ext cx="0" cy="0"/>
+          <a:chOff x="0" y="0"/>
+          <a:chExt cx="0" cy="0"/>
+        </a:xfrm>
+      </p:grpSpPr>
       <p:sp>
         <p:nvSpPr>
           <p:cNvPr id="2" name="Rectangle 1"/>
@@ -11670,6 +11884,7 @@
           <a:lstStyle/>
           <a:p>
             <a:pPr algn="ctr"/>
+            <a:endParaRPr/>
           </a:p>
         </p:txBody>
       </p:sp>
@@ -11714,6 +11929,7 @@
           <a:lstStyle/>
           <a:p>
             <a:pPr algn="ctr"/>
+            <a:endParaRPr/>
           </a:p>
         </p:txBody>
       </p:sp>
@@ -11734,7 +11950,7 @@
           <a:noFill/>
         </p:spPr>
         <p:txBody>
-          <a:bodyPr wrap="square" lIns="0" rIns="0" tIns="0" bIns="0" anchor="ctr">
+          <a:bodyPr wrap="square" lIns="0" tIns="0" rIns="0" bIns="0" anchor="ctr">
             <a:spAutoFit/>
           </a:bodyPr>
           <a:lstStyle/>
@@ -11769,7 +11985,7 @@
           <a:noFill/>
         </p:spPr>
         <p:txBody>
-          <a:bodyPr wrap="square" lIns="0" rIns="0" tIns="0" bIns="0">
+          <a:bodyPr wrap="square" lIns="0" tIns="0" rIns="0" bIns="0">
             <a:spAutoFit/>
           </a:bodyPr>
           <a:lstStyle/>
@@ -11808,7 +12024,7 @@
           <a:noFill/>
         </p:spPr>
         <p:txBody>
-          <a:bodyPr wrap="square" lIns="0" rIns="0" tIns="0" bIns="0">
+          <a:bodyPr wrap="square" lIns="0" tIns="0" rIns="0" bIns="0">
             <a:spAutoFit/>
           </a:bodyPr>
           <a:lstStyle/>
@@ -11867,6 +12083,7 @@
           <a:lstStyle/>
           <a:p>
             <a:pPr algn="ctr"/>
+            <a:endParaRPr/>
           </a:p>
         </p:txBody>
       </p:sp>
@@ -11887,7 +12104,7 @@
           <a:noFill/>
         </p:spPr>
         <p:txBody>
-          <a:bodyPr wrap="none" lIns="0" rIns="0" tIns="0" bIns="0">
+          <a:bodyPr wrap="none" lIns="0" tIns="0" rIns="0" bIns="0">
             <a:spAutoFit/>
           </a:bodyPr>
           <a:lstStyle/>
@@ -12014,6 +12231,7 @@
           <a:lstStyle/>
           <a:p>
             <a:pPr algn="ctr"/>
+            <a:endParaRPr/>
           </a:p>
         </p:txBody>
       </p:sp>
@@ -12034,7 +12252,7 @@
           <a:noFill/>
         </p:spPr>
         <p:txBody>
-          <a:bodyPr wrap="square" lIns="0" rIns="0" tIns="0" bIns="0">
+          <a:bodyPr wrap="square" lIns="0" tIns="0" rIns="0" bIns="0">
             <a:spAutoFit/>
           </a:bodyPr>
           <a:lstStyle/>
@@ -12069,7 +12287,7 @@
           <a:noFill/>
         </p:spPr>
         <p:txBody>
-          <a:bodyPr wrap="square" lIns="0" rIns="0" tIns="0" bIns="0">
+          <a:bodyPr wrap="square" lIns="0" tIns="0" rIns="0" bIns="0">
             <a:spAutoFit/>
           </a:bodyPr>
           <a:lstStyle/>
@@ -12140,7 +12358,7 @@
           <a:noFill/>
         </p:spPr>
         <p:txBody>
-          <a:bodyPr wrap="square" lIns="0" rIns="0" tIns="0" bIns="0">
+          <a:bodyPr wrap="square" lIns="0" tIns="0" rIns="0" bIns="0">
             <a:spAutoFit/>
           </a:bodyPr>
           <a:lstStyle/>
@@ -12167,7 +12385,7 @@
 </file>
 
 <file path=ppt/slides/slide9.xml><?xml version="1.0" encoding="utf-8"?>
-<p:sld xmlns:a="http://schemas.openxmlformats.org/drawingml/2006/main" xmlns:p="http://schemas.openxmlformats.org/presentationml/2006/main" xmlns:r="http://schemas.openxmlformats.org/officeDocument/2006/relationships">
+<p:sld xmlns:a="http://schemas.openxmlformats.org/drawingml/2006/main" xmlns:r="http://schemas.openxmlformats.org/officeDocument/2006/relationships" xmlns:p="http://schemas.openxmlformats.org/presentationml/2006/main">
   <p:cSld>
     <p:spTree>
       <p:nvGrpSpPr>
@@ -12175,7 +12393,14 @@
         <p:cNvGrpSpPr/>
         <p:nvPr/>
       </p:nvGrpSpPr>
-      <p:grpSpPr/>
+      <p:grpSpPr>
+        <a:xfrm>
+          <a:off x="0" y="0"/>
+          <a:ext cx="0" cy="0"/>
+          <a:chOff x="0" y="0"/>
+          <a:chExt cx="0" cy="0"/>
+        </a:xfrm>
+      </p:grpSpPr>
       <p:sp>
         <p:nvSpPr>
           <p:cNvPr id="2" name="Rectangle 1"/>
@@ -12217,6 +12442,7 @@
           <a:lstStyle/>
           <a:p>
             <a:pPr algn="ctr"/>
+            <a:endParaRPr/>
           </a:p>
         </p:txBody>
       </p:sp>
@@ -12261,6 +12487,7 @@
           <a:lstStyle/>
           <a:p>
             <a:pPr algn="ctr"/>
+            <a:endParaRPr/>
           </a:p>
         </p:txBody>
       </p:sp>
@@ -12281,7 +12508,7 @@
           <a:noFill/>
         </p:spPr>
         <p:txBody>
-          <a:bodyPr wrap="square" lIns="0" rIns="0" tIns="0" bIns="0" anchor="ctr">
+          <a:bodyPr wrap="square" lIns="0" tIns="0" rIns="0" bIns="0" anchor="ctr">
             <a:spAutoFit/>
           </a:bodyPr>
           <a:lstStyle/>
@@ -12316,7 +12543,7 @@
           <a:noFill/>
         </p:spPr>
         <p:txBody>
-          <a:bodyPr wrap="square" lIns="0" rIns="0" tIns="0" bIns="0">
+          <a:bodyPr wrap="square" lIns="0" tIns="0" rIns="0" bIns="0">
             <a:spAutoFit/>
           </a:bodyPr>
           <a:lstStyle/>
@@ -12355,7 +12582,7 @@
           <a:noFill/>
         </p:spPr>
         <p:txBody>
-          <a:bodyPr wrap="square" lIns="0" rIns="0" tIns="0" bIns="0">
+          <a:bodyPr wrap="square" lIns="0" tIns="0" rIns="0" bIns="0">
             <a:spAutoFit/>
           </a:bodyPr>
           <a:lstStyle/>
@@ -12414,6 +12641,7 @@
           <a:lstStyle/>
           <a:p>
             <a:pPr algn="ctr"/>
+            <a:endParaRPr/>
           </a:p>
         </p:txBody>
       </p:sp>
@@ -12434,7 +12662,7 @@
           <a:noFill/>
         </p:spPr>
         <p:txBody>
-          <a:bodyPr wrap="none" lIns="0" rIns="0" tIns="0" bIns="0">
+          <a:bodyPr wrap="none" lIns="0" tIns="0" rIns="0" bIns="0">
             <a:spAutoFit/>
           </a:bodyPr>
           <a:lstStyle/>
@@ -12545,6 +12773,7 @@
           <a:lstStyle/>
           <a:p>
             <a:pPr algn="ctr"/>
+            <a:endParaRPr/>
           </a:p>
         </p:txBody>
       </p:sp>
@@ -12565,7 +12794,7 @@
           <a:noFill/>
         </p:spPr>
         <p:txBody>
-          <a:bodyPr wrap="square" lIns="0" rIns="0" tIns="0" bIns="0">
+          <a:bodyPr wrap="square" lIns="0" tIns="0" rIns="0" bIns="0">
             <a:spAutoFit/>
           </a:bodyPr>
           <a:lstStyle/>
@@ -12600,7 +12829,7 @@
           <a:noFill/>
         </p:spPr>
         <p:txBody>
-          <a:bodyPr wrap="square" lIns="0" rIns="0" tIns="0" bIns="0">
+          <a:bodyPr wrap="square" lIns="0" tIns="0" rIns="0" bIns="0">
             <a:spAutoFit/>
           </a:bodyPr>
           <a:lstStyle/>
@@ -12671,7 +12900,7 @@
           <a:noFill/>
         </p:spPr>
         <p:txBody>
-          <a:bodyPr wrap="square" lIns="0" rIns="0" tIns="0" bIns="0">
+          <a:bodyPr wrap="square" lIns="0" tIns="0" rIns="0" bIns="0">
             <a:spAutoFit/>
           </a:bodyPr>
           <a:lstStyle/>

</xml_diff>